<commit_message>
Add actual Section 4.1 field checklist form to presentation
Replace bullet highlights with the full pre-test visual inspection
checklist from the Maintenance Strategy: checkpoint, accept/reject
criteria, and Pass/Fail/N/A sign-off columns plus inspector footer.

Co-authored-by: stavanparekh00-ai <stavanparekh00-ai@users.noreply.github.com>
</commit_message>
<xml_diff>
--- a/docs/presentation/UES-Steam-Safety-Program.pptx
+++ b/docs/presentation/UES-Steam-Safety-Program.pptx
@@ -6878,7 +6878,7 @@
               </a:defRPr>
             </a:pPr>
             <a:r>
-              <a:t>Pre-Test Field Checklist (Highlights)</a:t>
+              <a:t>Pre-Test Visual Inspection — Field Checklist</a:t>
             </a:r>
           </a:p>
         </p:txBody>
@@ -6913,7 +6913,7 @@
               </a:defRPr>
             </a:pPr>
             <a:r>
-              <a:t>Section 4.1 of Maintenance Strategy</a:t>
+              <a:t>Section 4.1 · Complete before every removal or in-place test · File in CMMS work order</a:t>
             </a:r>
           </a:p>
         </p:txBody>
@@ -6961,25 +6961,1069 @@
           </a:p>
         </p:txBody>
       </p:sp>
-      <p:sp>
-        <p:nvSpPr>
-          <p:cNvPr id="5" name="Rectangle 4"/>
+      <p:graphicFrame>
+        <p:nvGraphicFramePr>
+          <p:cNvPr id="5" name="Table 4"/>
+          <p:cNvGraphicFramePr>
+            <a:graphicFrameLocks noGrp="1"/>
+          </p:cNvGraphicFramePr>
+          <p:nvPr/>
+        </p:nvGraphicFramePr>
+        <p:xfrm>
+          <a:off x="594360" y="1325880"/>
+          <a:ext cx="10835640" cy="4892040"/>
+        </p:xfrm>
+        <a:graphic>
+          <a:graphicData uri="http://schemas.openxmlformats.org/drawingml/2006/table">
+            <a:tbl>
+              <a:tblPr firstRow="1" bandRow="1">
+                <a:tableStyleId>{5C22544A-7EE6-4342-B048-85BDC9FD1C3A}</a:tableStyleId>
+              </a:tblPr>
+              <a:tblGrid>
+                <a:gridCol w="2377440"/>
+                <a:gridCol w="6400800"/>
+                <a:gridCol w="685800"/>
+                <a:gridCol w="685800"/>
+                <a:gridCol w="685800"/>
+              </a:tblGrid>
+              <a:tr h="543560">
+                <a:tc>
+                  <a:txBody>
+                    <a:bodyPr/>
+                    <a:lstStyle/>
+                    <a:p>
+                      <a:pPr>
+                        <a:defRPr sz="1100" b="1">
+                          <a:solidFill>
+                            <a:srgbClr val="FFFFFF"/>
+                          </a:solidFill>
+                        </a:defRPr>
+                      </a:pPr>
+                      <a:r>
+                        <a:t>Checkpoint</a:t>
+                      </a:r>
+                    </a:p>
+                  </a:txBody>
+                  <a:tcPr anchor="ctr">
+                    <a:solidFill>
+                      <a:srgbClr val="500000"/>
+                    </a:solidFill>
+                  </a:tcPr>
+                </a:tc>
+                <a:tc>
+                  <a:txBody>
+                    <a:bodyPr/>
+                    <a:lstStyle/>
+                    <a:p>
+                      <a:pPr>
+                        <a:defRPr sz="1100" b="1">
+                          <a:solidFill>
+                            <a:srgbClr val="FFFFFF"/>
+                          </a:solidFill>
+                        </a:defRPr>
+                      </a:pPr>
+                      <a:r>
+                        <a:t>Accept / Reject criteria</a:t>
+                      </a:r>
+                    </a:p>
+                  </a:txBody>
+                  <a:tcPr anchor="ctr">
+                    <a:solidFill>
+                      <a:srgbClr val="500000"/>
+                    </a:solidFill>
+                  </a:tcPr>
+                </a:tc>
+                <a:tc>
+                  <a:txBody>
+                    <a:bodyPr/>
+                    <a:lstStyle/>
+                    <a:p>
+                      <a:pPr>
+                        <a:defRPr sz="1100" b="1">
+                          <a:solidFill>
+                            <a:srgbClr val="FFFFFF"/>
+                          </a:solidFill>
+                        </a:defRPr>
+                      </a:pPr>
+                      <a:r>
+                        <a:t>Pass</a:t>
+                      </a:r>
+                    </a:p>
+                  </a:txBody>
+                  <a:tcPr anchor="ctr">
+                    <a:solidFill>
+                      <a:srgbClr val="500000"/>
+                    </a:solidFill>
+                  </a:tcPr>
+                </a:tc>
+                <a:tc>
+                  <a:txBody>
+                    <a:bodyPr/>
+                    <a:lstStyle/>
+                    <a:p>
+                      <a:pPr>
+                        <a:defRPr sz="1100" b="1">
+                          <a:solidFill>
+                            <a:srgbClr val="FFFFFF"/>
+                          </a:solidFill>
+                        </a:defRPr>
+                      </a:pPr>
+                      <a:r>
+                        <a:t>Fail</a:t>
+                      </a:r>
+                    </a:p>
+                  </a:txBody>
+                  <a:tcPr anchor="ctr">
+                    <a:solidFill>
+                      <a:srgbClr val="500000"/>
+                    </a:solidFill>
+                  </a:tcPr>
+                </a:tc>
+                <a:tc>
+                  <a:txBody>
+                    <a:bodyPr/>
+                    <a:lstStyle/>
+                    <a:p>
+                      <a:pPr>
+                        <a:defRPr sz="1100" b="1">
+                          <a:solidFill>
+                            <a:srgbClr val="FFFFFF"/>
+                          </a:solidFill>
+                        </a:defRPr>
+                      </a:pPr>
+                      <a:r>
+                        <a:t>N/A</a:t>
+                      </a:r>
+                    </a:p>
+                  </a:txBody>
+                  <a:tcPr anchor="ctr">
+                    <a:solidFill>
+                      <a:srgbClr val="500000"/>
+                    </a:solidFill>
+                  </a:tcPr>
+                </a:tc>
+              </a:tr>
+              <a:tr h="543560">
+                <a:tc>
+                  <a:txBody>
+                    <a:bodyPr wrap="square"/>
+                    <a:lstStyle/>
+                    <a:p>
+                      <a:pPr>
+                        <a:defRPr sz="1000" b="0">
+                          <a:solidFill>
+                            <a:srgbClr val="1E293B"/>
+                          </a:solidFill>
+                        </a:defRPr>
+                      </a:pPr>
+                      <a:r>
+                        <a:t>Valve body and bonnet</a:t>
+                      </a:r>
+                    </a:p>
+                  </a:txBody>
+                  <a:tcPr anchor="ctr">
+                    <a:noFill/>
+                  </a:tcPr>
+                </a:tc>
+                <a:tc>
+                  <a:txBody>
+                    <a:bodyPr wrap="square"/>
+                    <a:lstStyle/>
+                    <a:p>
+                      <a:pPr>
+                        <a:defRPr sz="900" b="0">
+                          <a:solidFill>
+                            <a:srgbClr val="1E293B"/>
+                          </a:solidFill>
+                        </a:defRPr>
+                      </a:pPr>
+                      <a:r>
+                        <a:t>No active corrosion, pitting, or mechanical damage; minor surface rust OK if no pitting</a:t>
+                      </a:r>
+                    </a:p>
+                  </a:txBody>
+                  <a:tcPr anchor="ctr">
+                    <a:noFill/>
+                  </a:tcPr>
+                </a:tc>
+                <a:tc>
+                  <a:txBody>
+                    <a:bodyPr wrap="square"/>
+                    <a:lstStyle/>
+                    <a:p>
+                      <a:pPr algn="ctr">
+                        <a:defRPr sz="1000" b="0">
+                          <a:solidFill>
+                            <a:srgbClr val="1E293B"/>
+                          </a:solidFill>
+                        </a:defRPr>
+                      </a:pPr>
+                      <a:r>
+                        <a:t>☐</a:t>
+                      </a:r>
+                    </a:p>
+                  </a:txBody>
+                  <a:tcPr anchor="ctr">
+                    <a:noFill/>
+                  </a:tcPr>
+                </a:tc>
+                <a:tc>
+                  <a:txBody>
+                    <a:bodyPr wrap="square"/>
+                    <a:lstStyle/>
+                    <a:p>
+                      <a:pPr algn="ctr">
+                        <a:defRPr sz="1000" b="0">
+                          <a:solidFill>
+                            <a:srgbClr val="1E293B"/>
+                          </a:solidFill>
+                        </a:defRPr>
+                      </a:pPr>
+                      <a:r>
+                        <a:t>☐</a:t>
+                      </a:r>
+                    </a:p>
+                  </a:txBody>
+                  <a:tcPr anchor="ctr">
+                    <a:noFill/>
+                  </a:tcPr>
+                </a:tc>
+                <a:tc>
+                  <a:txBody>
+                    <a:bodyPr wrap="square"/>
+                    <a:lstStyle/>
+                    <a:p>
+                      <a:pPr algn="ctr">
+                        <a:defRPr sz="1000" b="0">
+                          <a:solidFill>
+                            <a:srgbClr val="1E293B"/>
+                          </a:solidFill>
+                        </a:defRPr>
+                      </a:pPr>
+                      <a:r>
+                        <a:t>☐</a:t>
+                      </a:r>
+                    </a:p>
+                  </a:txBody>
+                  <a:tcPr anchor="ctr">
+                    <a:noFill/>
+                  </a:tcPr>
+                </a:tc>
+              </a:tr>
+              <a:tr h="543560">
+                <a:tc>
+                  <a:txBody>
+                    <a:bodyPr wrap="square"/>
+                    <a:lstStyle/>
+                    <a:p>
+                      <a:pPr>
+                        <a:defRPr sz="1000" b="0">
+                          <a:solidFill>
+                            <a:srgbClr val="1E293B"/>
+                          </a:solidFill>
+                        </a:defRPr>
+                      </a:pPr>
+                      <a:r>
+                        <a:t>Discharge pipe / stack</a:t>
+                      </a:r>
+                    </a:p>
+                  </a:txBody>
+                  <a:tcPr anchor="ctr">
+                    <a:solidFill>
+                      <a:srgbClr val="F8FAFC"/>
+                    </a:solidFill>
+                  </a:tcPr>
+                </a:tc>
+                <a:tc>
+                  <a:txBody>
+                    <a:bodyPr wrap="square"/>
+                    <a:lstStyle/>
+                    <a:p>
+                      <a:pPr>
+                        <a:defRPr sz="900" b="0">
+                          <a:solidFill>
+                            <a:srgbClr val="1E293B"/>
+                          </a:solidFill>
+                        </a:defRPr>
+                      </a:pPr>
+                      <a:r>
+                        <a:t>Clear and unobstructed; properly supported; no standing water; drip pocket if applicable</a:t>
+                      </a:r>
+                    </a:p>
+                  </a:txBody>
+                  <a:tcPr anchor="ctr">
+                    <a:solidFill>
+                      <a:srgbClr val="F8FAFC"/>
+                    </a:solidFill>
+                  </a:tcPr>
+                </a:tc>
+                <a:tc>
+                  <a:txBody>
+                    <a:bodyPr wrap="square"/>
+                    <a:lstStyle/>
+                    <a:p>
+                      <a:pPr algn="ctr">
+                        <a:defRPr sz="1000" b="0">
+                          <a:solidFill>
+                            <a:srgbClr val="1E293B"/>
+                          </a:solidFill>
+                        </a:defRPr>
+                      </a:pPr>
+                      <a:r>
+                        <a:t>☐</a:t>
+                      </a:r>
+                    </a:p>
+                  </a:txBody>
+                  <a:tcPr anchor="ctr">
+                    <a:solidFill>
+                      <a:srgbClr val="F8FAFC"/>
+                    </a:solidFill>
+                  </a:tcPr>
+                </a:tc>
+                <a:tc>
+                  <a:txBody>
+                    <a:bodyPr wrap="square"/>
+                    <a:lstStyle/>
+                    <a:p>
+                      <a:pPr algn="ctr">
+                        <a:defRPr sz="1000" b="0">
+                          <a:solidFill>
+                            <a:srgbClr val="1E293B"/>
+                          </a:solidFill>
+                        </a:defRPr>
+                      </a:pPr>
+                      <a:r>
+                        <a:t>☐</a:t>
+                      </a:r>
+                    </a:p>
+                  </a:txBody>
+                  <a:tcPr anchor="ctr">
+                    <a:solidFill>
+                      <a:srgbClr val="F8FAFC"/>
+                    </a:solidFill>
+                  </a:tcPr>
+                </a:tc>
+                <a:tc>
+                  <a:txBody>
+                    <a:bodyPr wrap="square"/>
+                    <a:lstStyle/>
+                    <a:p>
+                      <a:pPr algn="ctr">
+                        <a:defRPr sz="1000" b="0">
+                          <a:solidFill>
+                            <a:srgbClr val="1E293B"/>
+                          </a:solidFill>
+                        </a:defRPr>
+                      </a:pPr>
+                      <a:r>
+                        <a:t>☐</a:t>
+                      </a:r>
+                    </a:p>
+                  </a:txBody>
+                  <a:tcPr anchor="ctr">
+                    <a:solidFill>
+                      <a:srgbClr val="F8FAFC"/>
+                    </a:solidFill>
+                  </a:tcPr>
+                </a:tc>
+              </a:tr>
+              <a:tr h="543560">
+                <a:tc>
+                  <a:txBody>
+                    <a:bodyPr wrap="square"/>
+                    <a:lstStyle/>
+                    <a:p>
+                      <a:pPr>
+                        <a:defRPr sz="1000" b="0">
+                          <a:solidFill>
+                            <a:srgbClr val="1E293B"/>
+                          </a:solidFill>
+                        </a:defRPr>
+                      </a:pPr>
+                      <a:r>
+                        <a:t>Drain / weep hole (if equipped)</a:t>
+                      </a:r>
+                    </a:p>
+                  </a:txBody>
+                  <a:tcPr anchor="ctr">
+                    <a:noFill/>
+                  </a:tcPr>
+                </a:tc>
+                <a:tc>
+                  <a:txBody>
+                    <a:bodyPr wrap="square"/>
+                    <a:lstStyle/>
+                    <a:p>
+                      <a:pPr>
+                        <a:defRPr sz="900" b="0">
+                          <a:solidFill>
+                            <a:srgbClr val="1E293B"/>
+                          </a:solidFill>
+                        </a:defRPr>
+                      </a:pPr>
+                      <a:r>
+                        <a:t>Open and unobstructed; no plugging or paint blockage</a:t>
+                      </a:r>
+                    </a:p>
+                  </a:txBody>
+                  <a:tcPr anchor="ctr">
+                    <a:noFill/>
+                  </a:tcPr>
+                </a:tc>
+                <a:tc>
+                  <a:txBody>
+                    <a:bodyPr wrap="square"/>
+                    <a:lstStyle/>
+                    <a:p>
+                      <a:pPr algn="ctr">
+                        <a:defRPr sz="1000" b="0">
+                          <a:solidFill>
+                            <a:srgbClr val="1E293B"/>
+                          </a:solidFill>
+                        </a:defRPr>
+                      </a:pPr>
+                      <a:r>
+                        <a:t>☐</a:t>
+                      </a:r>
+                    </a:p>
+                  </a:txBody>
+                  <a:tcPr anchor="ctr">
+                    <a:noFill/>
+                  </a:tcPr>
+                </a:tc>
+                <a:tc>
+                  <a:txBody>
+                    <a:bodyPr wrap="square"/>
+                    <a:lstStyle/>
+                    <a:p>
+                      <a:pPr algn="ctr">
+                        <a:defRPr sz="1000" b="0">
+                          <a:solidFill>
+                            <a:srgbClr val="1E293B"/>
+                          </a:solidFill>
+                        </a:defRPr>
+                      </a:pPr>
+                      <a:r>
+                        <a:t>☐</a:t>
+                      </a:r>
+                    </a:p>
+                  </a:txBody>
+                  <a:tcPr anchor="ctr">
+                    <a:noFill/>
+                  </a:tcPr>
+                </a:tc>
+                <a:tc>
+                  <a:txBody>
+                    <a:bodyPr wrap="square"/>
+                    <a:lstStyle/>
+                    <a:p>
+                      <a:pPr algn="ctr">
+                        <a:defRPr sz="1000" b="0">
+                          <a:solidFill>
+                            <a:srgbClr val="1E293B"/>
+                          </a:solidFill>
+                        </a:defRPr>
+                      </a:pPr>
+                      <a:r>
+                        <a:t>☐</a:t>
+                      </a:r>
+                    </a:p>
+                  </a:txBody>
+                  <a:tcPr anchor="ctr">
+                    <a:noFill/>
+                  </a:tcPr>
+                </a:tc>
+              </a:tr>
+              <a:tr h="543560">
+                <a:tc>
+                  <a:txBody>
+                    <a:bodyPr wrap="square"/>
+                    <a:lstStyle/>
+                    <a:p>
+                      <a:pPr>
+                        <a:defRPr sz="1000" b="0">
+                          <a:solidFill>
+                            <a:srgbClr val="1E293B"/>
+                          </a:solidFill>
+                        </a:defRPr>
+                      </a:pPr>
+                      <a:r>
+                        <a:t>Body and bonnet bolting</a:t>
+                      </a:r>
+                    </a:p>
+                  </a:txBody>
+                  <a:tcPr anchor="ctr">
+                    <a:solidFill>
+                      <a:srgbClr val="F8FAFC"/>
+                    </a:solidFill>
+                  </a:tcPr>
+                </a:tc>
+                <a:tc>
+                  <a:txBody>
+                    <a:bodyPr wrap="square"/>
+                    <a:lstStyle/>
+                    <a:p>
+                      <a:pPr>
+                        <a:defRPr sz="900" b="0">
+                          <a:solidFill>
+                            <a:srgbClr val="1E293B"/>
+                          </a:solidFill>
+                        </a:defRPr>
+                      </a:pPr>
+                      <a:r>
+                        <a:t>All fasteners present and intact; no visible cracks or corrosion</a:t>
+                      </a:r>
+                    </a:p>
+                  </a:txBody>
+                  <a:tcPr anchor="ctr">
+                    <a:solidFill>
+                      <a:srgbClr val="F8FAFC"/>
+                    </a:solidFill>
+                  </a:tcPr>
+                </a:tc>
+                <a:tc>
+                  <a:txBody>
+                    <a:bodyPr wrap="square"/>
+                    <a:lstStyle/>
+                    <a:p>
+                      <a:pPr algn="ctr">
+                        <a:defRPr sz="1000" b="0">
+                          <a:solidFill>
+                            <a:srgbClr val="1E293B"/>
+                          </a:solidFill>
+                        </a:defRPr>
+                      </a:pPr>
+                      <a:r>
+                        <a:t>☐</a:t>
+                      </a:r>
+                    </a:p>
+                  </a:txBody>
+                  <a:tcPr anchor="ctr">
+                    <a:solidFill>
+                      <a:srgbClr val="F8FAFC"/>
+                    </a:solidFill>
+                  </a:tcPr>
+                </a:tc>
+                <a:tc>
+                  <a:txBody>
+                    <a:bodyPr wrap="square"/>
+                    <a:lstStyle/>
+                    <a:p>
+                      <a:pPr algn="ctr">
+                        <a:defRPr sz="1000" b="0">
+                          <a:solidFill>
+                            <a:srgbClr val="1E293B"/>
+                          </a:solidFill>
+                        </a:defRPr>
+                      </a:pPr>
+                      <a:r>
+                        <a:t>☐</a:t>
+                      </a:r>
+                    </a:p>
+                  </a:txBody>
+                  <a:tcPr anchor="ctr">
+                    <a:solidFill>
+                      <a:srgbClr val="F8FAFC"/>
+                    </a:solidFill>
+                  </a:tcPr>
+                </a:tc>
+                <a:tc>
+                  <a:txBody>
+                    <a:bodyPr wrap="square"/>
+                    <a:lstStyle/>
+                    <a:p>
+                      <a:pPr algn="ctr">
+                        <a:defRPr sz="1000" b="0">
+                          <a:solidFill>
+                            <a:srgbClr val="1E293B"/>
+                          </a:solidFill>
+                        </a:defRPr>
+                      </a:pPr>
+                      <a:r>
+                        <a:t>☐</a:t>
+                      </a:r>
+                    </a:p>
+                  </a:txBody>
+                  <a:tcPr anchor="ctr">
+                    <a:solidFill>
+                      <a:srgbClr val="F8FAFC"/>
+                    </a:solidFill>
+                  </a:tcPr>
+                </a:tc>
+              </a:tr>
+              <a:tr h="543560">
+                <a:tc>
+                  <a:txBody>
+                    <a:bodyPr wrap="square"/>
+                    <a:lstStyle/>
+                    <a:p>
+                      <a:pPr>
+                        <a:defRPr sz="1000" b="0">
+                          <a:solidFill>
+                            <a:srgbClr val="1E293B"/>
+                          </a:solidFill>
+                        </a:defRPr>
+                      </a:pPr>
+                      <a:r>
+                        <a:t>Nameplate legibility</a:t>
+                      </a:r>
+                    </a:p>
+                  </a:txBody>
+                  <a:tcPr anchor="ctr">
+                    <a:noFill/>
+                  </a:tcPr>
+                </a:tc>
+                <a:tc>
+                  <a:txBody>
+                    <a:bodyPr wrap="square"/>
+                    <a:lstStyle/>
+                    <a:p>
+                      <a:pPr>
+                        <a:defRPr sz="900" b="0">
+                          <a:solidFill>
+                            <a:srgbClr val="1E293B"/>
+                          </a:solidFill>
+                        </a:defRPr>
+                      </a:pPr>
+                      <a:r>
+                        <a:t>CDTP, serial number, orifice, and manufacture year legible — record in work order</a:t>
+                      </a:r>
+                    </a:p>
+                  </a:txBody>
+                  <a:tcPr anchor="ctr">
+                    <a:noFill/>
+                  </a:tcPr>
+                </a:tc>
+                <a:tc>
+                  <a:txBody>
+                    <a:bodyPr wrap="square"/>
+                    <a:lstStyle/>
+                    <a:p>
+                      <a:pPr algn="ctr">
+                        <a:defRPr sz="1000" b="0">
+                          <a:solidFill>
+                            <a:srgbClr val="1E293B"/>
+                          </a:solidFill>
+                        </a:defRPr>
+                      </a:pPr>
+                      <a:r>
+                        <a:t>☐</a:t>
+                      </a:r>
+                    </a:p>
+                  </a:txBody>
+                  <a:tcPr anchor="ctr">
+                    <a:noFill/>
+                  </a:tcPr>
+                </a:tc>
+                <a:tc>
+                  <a:txBody>
+                    <a:bodyPr wrap="square"/>
+                    <a:lstStyle/>
+                    <a:p>
+                      <a:pPr algn="ctr">
+                        <a:defRPr sz="1000" b="0">
+                          <a:solidFill>
+                            <a:srgbClr val="1E293B"/>
+                          </a:solidFill>
+                        </a:defRPr>
+                      </a:pPr>
+                      <a:r>
+                        <a:t>☐</a:t>
+                      </a:r>
+                    </a:p>
+                  </a:txBody>
+                  <a:tcPr anchor="ctr">
+                    <a:noFill/>
+                  </a:tcPr>
+                </a:tc>
+                <a:tc>
+                  <a:txBody>
+                    <a:bodyPr wrap="square"/>
+                    <a:lstStyle/>
+                    <a:p>
+                      <a:pPr algn="ctr">
+                        <a:defRPr sz="1000" b="0">
+                          <a:solidFill>
+                            <a:srgbClr val="1E293B"/>
+                          </a:solidFill>
+                        </a:defRPr>
+                      </a:pPr>
+                      <a:r>
+                        <a:t>☐</a:t>
+                      </a:r>
+                    </a:p>
+                  </a:txBody>
+                  <a:tcPr anchor="ctr">
+                    <a:noFill/>
+                  </a:tcPr>
+                </a:tc>
+              </a:tr>
+              <a:tr h="543560">
+                <a:tc>
+                  <a:txBody>
+                    <a:bodyPr wrap="square"/>
+                    <a:lstStyle/>
+                    <a:p>
+                      <a:pPr>
+                        <a:defRPr sz="1000" b="0">
+                          <a:solidFill>
+                            <a:srgbClr val="1E293B"/>
+                          </a:solidFill>
+                        </a:defRPr>
+                      </a:pPr>
+                      <a:r>
+                        <a:t>Inlet / nozzle area</a:t>
+                      </a:r>
+                    </a:p>
+                  </a:txBody>
+                  <a:tcPr anchor="ctr">
+                    <a:solidFill>
+                      <a:srgbClr val="F8FAFC"/>
+                    </a:solidFill>
+                  </a:tcPr>
+                </a:tc>
+                <a:tc>
+                  <a:txBody>
+                    <a:bodyPr wrap="square"/>
+                    <a:lstStyle/>
+                    <a:p>
+                      <a:pPr>
+                        <a:defRPr sz="900" b="0">
+                          <a:solidFill>
+                            <a:srgbClr val="1E293B"/>
+                          </a:solidFill>
+                        </a:defRPr>
+                      </a:pPr>
+                      <a:r>
+                        <a:t>No visible leakage or weeping at seat; dry mating surfaces</a:t>
+                      </a:r>
+                    </a:p>
+                  </a:txBody>
+                  <a:tcPr anchor="ctr">
+                    <a:solidFill>
+                      <a:srgbClr val="F8FAFC"/>
+                    </a:solidFill>
+                  </a:tcPr>
+                </a:tc>
+                <a:tc>
+                  <a:txBody>
+                    <a:bodyPr wrap="square"/>
+                    <a:lstStyle/>
+                    <a:p>
+                      <a:pPr algn="ctr">
+                        <a:defRPr sz="1000" b="0">
+                          <a:solidFill>
+                            <a:srgbClr val="1E293B"/>
+                          </a:solidFill>
+                        </a:defRPr>
+                      </a:pPr>
+                      <a:r>
+                        <a:t>☐</a:t>
+                      </a:r>
+                    </a:p>
+                  </a:txBody>
+                  <a:tcPr anchor="ctr">
+                    <a:solidFill>
+                      <a:srgbClr val="F8FAFC"/>
+                    </a:solidFill>
+                  </a:tcPr>
+                </a:tc>
+                <a:tc>
+                  <a:txBody>
+                    <a:bodyPr wrap="square"/>
+                    <a:lstStyle/>
+                    <a:p>
+                      <a:pPr algn="ctr">
+                        <a:defRPr sz="1000" b="0">
+                          <a:solidFill>
+                            <a:srgbClr val="1E293B"/>
+                          </a:solidFill>
+                        </a:defRPr>
+                      </a:pPr>
+                      <a:r>
+                        <a:t>☐</a:t>
+                      </a:r>
+                    </a:p>
+                  </a:txBody>
+                  <a:tcPr anchor="ctr">
+                    <a:solidFill>
+                      <a:srgbClr val="F8FAFC"/>
+                    </a:solidFill>
+                  </a:tcPr>
+                </a:tc>
+                <a:tc>
+                  <a:txBody>
+                    <a:bodyPr wrap="square"/>
+                    <a:lstStyle/>
+                    <a:p>
+                      <a:pPr algn="ctr">
+                        <a:defRPr sz="1000" b="0">
+                          <a:solidFill>
+                            <a:srgbClr val="1E293B"/>
+                          </a:solidFill>
+                        </a:defRPr>
+                      </a:pPr>
+                      <a:r>
+                        <a:t>☐</a:t>
+                      </a:r>
+                    </a:p>
+                  </a:txBody>
+                  <a:tcPr anchor="ctr">
+                    <a:solidFill>
+                      <a:srgbClr val="F8FAFC"/>
+                    </a:solidFill>
+                  </a:tcPr>
+                </a:tc>
+              </a:tr>
+              <a:tr h="543560">
+                <a:tc>
+                  <a:txBody>
+                    <a:bodyPr wrap="square"/>
+                    <a:lstStyle/>
+                    <a:p>
+                      <a:pPr>
+                        <a:defRPr sz="1000" b="0">
+                          <a:solidFill>
+                            <a:srgbClr val="1E293B"/>
+                          </a:solidFill>
+                        </a:defRPr>
+                      </a:pPr>
+                      <a:r>
+                        <a:t>Test gag / lifting lever</a:t>
+                      </a:r>
+                    </a:p>
+                  </a:txBody>
+                  <a:tcPr anchor="ctr">
+                    <a:noFill/>
+                  </a:tcPr>
+                </a:tc>
+                <a:tc>
+                  <a:txBody>
+                    <a:bodyPr wrap="square"/>
+                    <a:lstStyle/>
+                    <a:p>
+                      <a:pPr>
+                        <a:defRPr sz="900" b="0">
+                          <a:solidFill>
+                            <a:srgbClr val="1E293B"/>
+                          </a:solidFill>
+                        </a:defRPr>
+                      </a:pPr>
+                      <a:r>
+                        <a:t>Free of obstructions; lever not locked or wired shut (if equipped)</a:t>
+                      </a:r>
+                    </a:p>
+                  </a:txBody>
+                  <a:tcPr anchor="ctr">
+                    <a:noFill/>
+                  </a:tcPr>
+                </a:tc>
+                <a:tc>
+                  <a:txBody>
+                    <a:bodyPr wrap="square"/>
+                    <a:lstStyle/>
+                    <a:p>
+                      <a:pPr algn="ctr">
+                        <a:defRPr sz="1000" b="0">
+                          <a:solidFill>
+                            <a:srgbClr val="1E293B"/>
+                          </a:solidFill>
+                        </a:defRPr>
+                      </a:pPr>
+                      <a:r>
+                        <a:t>☐</a:t>
+                      </a:r>
+                    </a:p>
+                  </a:txBody>
+                  <a:tcPr anchor="ctr">
+                    <a:noFill/>
+                  </a:tcPr>
+                </a:tc>
+                <a:tc>
+                  <a:txBody>
+                    <a:bodyPr wrap="square"/>
+                    <a:lstStyle/>
+                    <a:p>
+                      <a:pPr algn="ctr">
+                        <a:defRPr sz="1000" b="0">
+                          <a:solidFill>
+                            <a:srgbClr val="1E293B"/>
+                          </a:solidFill>
+                        </a:defRPr>
+                      </a:pPr>
+                      <a:r>
+                        <a:t>☐</a:t>
+                      </a:r>
+                    </a:p>
+                  </a:txBody>
+                  <a:tcPr anchor="ctr">
+                    <a:noFill/>
+                  </a:tcPr>
+                </a:tc>
+                <a:tc>
+                  <a:txBody>
+                    <a:bodyPr wrap="square"/>
+                    <a:lstStyle/>
+                    <a:p>
+                      <a:pPr algn="ctr">
+                        <a:defRPr sz="1000" b="0">
+                          <a:solidFill>
+                            <a:srgbClr val="1E293B"/>
+                          </a:solidFill>
+                        </a:defRPr>
+                      </a:pPr>
+                      <a:r>
+                        <a:t>☐</a:t>
+                      </a:r>
+                    </a:p>
+                  </a:txBody>
+                  <a:tcPr anchor="ctr">
+                    <a:noFill/>
+                  </a:tcPr>
+                </a:tc>
+              </a:tr>
+              <a:tr h="543560">
+                <a:tc>
+                  <a:txBody>
+                    <a:bodyPr wrap="square"/>
+                    <a:lstStyle/>
+                    <a:p>
+                      <a:pPr>
+                        <a:defRPr sz="1000" b="0">
+                          <a:solidFill>
+                            <a:srgbClr val="1E293B"/>
+                          </a:solidFill>
+                        </a:defRPr>
+                      </a:pPr>
+                      <a:r>
+                        <a:t>Inlet isolation (if applicable)</a:t>
+                      </a:r>
+                    </a:p>
+                  </a:txBody>
+                  <a:tcPr anchor="ctr">
+                    <a:solidFill>
+                      <a:srgbClr val="F8FAFC"/>
+                    </a:solidFill>
+                  </a:tcPr>
+                </a:tc>
+                <a:tc>
+                  <a:txBody>
+                    <a:bodyPr wrap="square"/>
+                    <a:lstStyle/>
+                    <a:p>
+                      <a:pPr>
+                        <a:defRPr sz="900" b="0">
+                          <a:solidFill>
+                            <a:srgbClr val="1E293B"/>
+                          </a:solidFill>
+                        </a:defRPr>
+                      </a:pPr>
+                      <a:r>
+                        <a:t>Valve in-line and not inadvertently isolated</a:t>
+                      </a:r>
+                    </a:p>
+                  </a:txBody>
+                  <a:tcPr anchor="ctr">
+                    <a:solidFill>
+                      <a:srgbClr val="F8FAFC"/>
+                    </a:solidFill>
+                  </a:tcPr>
+                </a:tc>
+                <a:tc>
+                  <a:txBody>
+                    <a:bodyPr wrap="square"/>
+                    <a:lstStyle/>
+                    <a:p>
+                      <a:pPr algn="ctr">
+                        <a:defRPr sz="1000" b="0">
+                          <a:solidFill>
+                            <a:srgbClr val="1E293B"/>
+                          </a:solidFill>
+                        </a:defRPr>
+                      </a:pPr>
+                      <a:r>
+                        <a:t>☐</a:t>
+                      </a:r>
+                    </a:p>
+                  </a:txBody>
+                  <a:tcPr anchor="ctr">
+                    <a:solidFill>
+                      <a:srgbClr val="F8FAFC"/>
+                    </a:solidFill>
+                  </a:tcPr>
+                </a:tc>
+                <a:tc>
+                  <a:txBody>
+                    <a:bodyPr wrap="square"/>
+                    <a:lstStyle/>
+                    <a:p>
+                      <a:pPr algn="ctr">
+                        <a:defRPr sz="1000" b="0">
+                          <a:solidFill>
+                            <a:srgbClr val="1E293B"/>
+                          </a:solidFill>
+                        </a:defRPr>
+                      </a:pPr>
+                      <a:r>
+                        <a:t>☐</a:t>
+                      </a:r>
+                    </a:p>
+                  </a:txBody>
+                  <a:tcPr anchor="ctr">
+                    <a:solidFill>
+                      <a:srgbClr val="F8FAFC"/>
+                    </a:solidFill>
+                  </a:tcPr>
+                </a:tc>
+                <a:tc>
+                  <a:txBody>
+                    <a:bodyPr wrap="square"/>
+                    <a:lstStyle/>
+                    <a:p>
+                      <a:pPr algn="ctr">
+                        <a:defRPr sz="1000" b="0">
+                          <a:solidFill>
+                            <a:srgbClr val="1E293B"/>
+                          </a:solidFill>
+                        </a:defRPr>
+                      </a:pPr>
+                      <a:r>
+                        <a:t>☐</a:t>
+                      </a:r>
+                    </a:p>
+                  </a:txBody>
+                  <a:tcPr anchor="ctr">
+                    <a:solidFill>
+                      <a:srgbClr val="F8FAFC"/>
+                    </a:solidFill>
+                  </a:tcPr>
+                </a:tc>
+              </a:tr>
+            </a:tbl>
+          </a:graphicData>
+        </a:graphic>
+      </p:graphicFrame>
+      <p:sp>
+        <p:nvSpPr>
+          <p:cNvPr id="6" name="Rectangle 5"/>
           <p:cNvSpPr/>
           <p:nvPr/>
         </p:nvSpPr>
         <p:spPr>
           <a:xfrm>
-            <a:off x="685800" y="1426464"/>
-            <a:ext cx="164592" cy="164592"/>
+            <a:off x="594360" y="6053328"/>
+            <a:ext cx="10972800" cy="384048"/>
           </a:xfrm>
           <a:prstGeom prst="rect">
             <a:avLst/>
           </a:prstGeom>
           <a:solidFill>
-            <a:srgbClr val="B83A3A"/>
+            <a:srgbClr val="FFFBEB"/>
           </a:solidFill>
           <a:ln>
-            <a:noFill/>
+            <a:solidFill>
+              <a:srgbClr val="B83A3A"/>
+            </a:solidFill>
           </a:ln>
         </p:spPr>
         <p:style>
@@ -7000,41 +8044,15 @@
           <a:bodyPr rtlCol="0" anchor="ctr"/>
           <a:lstStyle/>
           <a:p>
-            <a:pPr algn="ctr"/>
-          </a:p>
-        </p:txBody>
-      </p:sp>
-      <p:sp>
-        <p:nvSpPr>
-          <p:cNvPr id="6" name="TextBox 5"/>
-          <p:cNvSpPr txBox="1"/>
-          <p:nvPr/>
-        </p:nvSpPr>
-        <p:spPr>
-          <a:xfrm>
-            <a:off x="960120" y="1353312"/>
-            <a:ext cx="10424160" cy="566928"/>
-          </a:xfrm>
-          <a:prstGeom prst="rect">
-            <a:avLst/>
-          </a:prstGeom>
-          <a:noFill/>
-        </p:spPr>
-        <p:txBody>
-          <a:bodyPr wrap="square">
-            <a:spAutoFit/>
-          </a:bodyPr>
-          <a:lstStyle/>
-          <a:p>
-            <a:pPr>
-              <a:defRPr sz="1600" b="0">
+            <a:pPr algn="ctr">
+              <a:defRPr sz="1000" b="1">
                 <a:solidFill>
                   <a:srgbClr val="1E293B"/>
                 </a:solidFill>
               </a:defRPr>
             </a:pPr>
             <a:r>
-              <a:t>Valve body/bonnet — no active corrosion or mechanical damage</a:t>
+              <a:t>Inspector: _________________________   Date: __________   WO #: __________   Equipment / Location: _________________________</a:t>
             </a:r>
           </a:p>
         </p:txBody>
@@ -7042,396 +8060,6 @@
       <p:sp>
         <p:nvSpPr>
           <p:cNvPr id="7" name="Rectangle 6"/>
-          <p:cNvSpPr/>
-          <p:nvPr/>
-        </p:nvSpPr>
-        <p:spPr>
-          <a:xfrm>
-            <a:off x="685800" y="2084832"/>
-            <a:ext cx="164592" cy="164592"/>
-          </a:xfrm>
-          <a:prstGeom prst="rect">
-            <a:avLst/>
-          </a:prstGeom>
-          <a:solidFill>
-            <a:srgbClr val="B83A3A"/>
-          </a:solidFill>
-          <a:ln>
-            <a:noFill/>
-          </a:ln>
-        </p:spPr>
-        <p:style>
-          <a:lnRef idx="1">
-            <a:schemeClr val="accent1"/>
-          </a:lnRef>
-          <a:fillRef idx="3">
-            <a:schemeClr val="accent1"/>
-          </a:fillRef>
-          <a:effectRef idx="2">
-            <a:schemeClr val="accent1"/>
-          </a:effectRef>
-          <a:fontRef idx="minor">
-            <a:schemeClr val="lt1"/>
-          </a:fontRef>
-        </p:style>
-        <p:txBody>
-          <a:bodyPr rtlCol="0" anchor="ctr"/>
-          <a:lstStyle/>
-          <a:p>
-            <a:pPr algn="ctr"/>
-          </a:p>
-        </p:txBody>
-      </p:sp>
-      <p:sp>
-        <p:nvSpPr>
-          <p:cNvPr id="8" name="TextBox 7"/>
-          <p:cNvSpPr txBox="1"/>
-          <p:nvPr/>
-        </p:nvSpPr>
-        <p:spPr>
-          <a:xfrm>
-            <a:off x="960120" y="2011680"/>
-            <a:ext cx="10424160" cy="566928"/>
-          </a:xfrm>
-          <a:prstGeom prst="rect">
-            <a:avLst/>
-          </a:prstGeom>
-          <a:noFill/>
-        </p:spPr>
-        <p:txBody>
-          <a:bodyPr wrap="square">
-            <a:spAutoFit/>
-          </a:bodyPr>
-          <a:lstStyle/>
-          <a:p>
-            <a:pPr>
-              <a:defRPr sz="1600" b="0">
-                <a:solidFill>
-                  <a:srgbClr val="1E293B"/>
-                </a:solidFill>
-              </a:defRPr>
-            </a:pPr>
-            <a:r>
-              <a:t>Discharge stack — clear, supported, no standing water</a:t>
-            </a:r>
-          </a:p>
-        </p:txBody>
-      </p:sp>
-      <p:sp>
-        <p:nvSpPr>
-          <p:cNvPr id="9" name="Rectangle 8"/>
-          <p:cNvSpPr/>
-          <p:nvPr/>
-        </p:nvSpPr>
-        <p:spPr>
-          <a:xfrm>
-            <a:off x="685800" y="2743200"/>
-            <a:ext cx="164592" cy="164592"/>
-          </a:xfrm>
-          <a:prstGeom prst="rect">
-            <a:avLst/>
-          </a:prstGeom>
-          <a:solidFill>
-            <a:srgbClr val="B83A3A"/>
-          </a:solidFill>
-          <a:ln>
-            <a:noFill/>
-          </a:ln>
-        </p:spPr>
-        <p:style>
-          <a:lnRef idx="1">
-            <a:schemeClr val="accent1"/>
-          </a:lnRef>
-          <a:fillRef idx="3">
-            <a:schemeClr val="accent1"/>
-          </a:fillRef>
-          <a:effectRef idx="2">
-            <a:schemeClr val="accent1"/>
-          </a:effectRef>
-          <a:fontRef idx="minor">
-            <a:schemeClr val="lt1"/>
-          </a:fontRef>
-        </p:style>
-        <p:txBody>
-          <a:bodyPr rtlCol="0" anchor="ctr"/>
-          <a:lstStyle/>
-          <a:p>
-            <a:pPr algn="ctr"/>
-          </a:p>
-        </p:txBody>
-      </p:sp>
-      <p:sp>
-        <p:nvSpPr>
-          <p:cNvPr id="10" name="TextBox 9"/>
-          <p:cNvSpPr txBox="1"/>
-          <p:nvPr/>
-        </p:nvSpPr>
-        <p:spPr>
-          <a:xfrm>
-            <a:off x="960120" y="2670048"/>
-            <a:ext cx="10424160" cy="566928"/>
-          </a:xfrm>
-          <a:prstGeom prst="rect">
-            <a:avLst/>
-          </a:prstGeom>
-          <a:noFill/>
-        </p:spPr>
-        <p:txBody>
-          <a:bodyPr wrap="square">
-            <a:spAutoFit/>
-          </a:bodyPr>
-          <a:lstStyle/>
-          <a:p>
-            <a:pPr>
-              <a:defRPr sz="1600" b="0">
-                <a:solidFill>
-                  <a:srgbClr val="1E293B"/>
-                </a:solidFill>
-              </a:defRPr>
-            </a:pPr>
-            <a:r>
-              <a:t>Nameplate legible — record set pressure, serial, orifice, manufacture year</a:t>
-            </a:r>
-          </a:p>
-        </p:txBody>
-      </p:sp>
-      <p:sp>
-        <p:nvSpPr>
-          <p:cNvPr id="11" name="Rectangle 10"/>
-          <p:cNvSpPr/>
-          <p:nvPr/>
-        </p:nvSpPr>
-        <p:spPr>
-          <a:xfrm>
-            <a:off x="685800" y="3401568"/>
-            <a:ext cx="164592" cy="164592"/>
-          </a:xfrm>
-          <a:prstGeom prst="rect">
-            <a:avLst/>
-          </a:prstGeom>
-          <a:solidFill>
-            <a:srgbClr val="B83A3A"/>
-          </a:solidFill>
-          <a:ln>
-            <a:noFill/>
-          </a:ln>
-        </p:spPr>
-        <p:style>
-          <a:lnRef idx="1">
-            <a:schemeClr val="accent1"/>
-          </a:lnRef>
-          <a:fillRef idx="3">
-            <a:schemeClr val="accent1"/>
-          </a:fillRef>
-          <a:effectRef idx="2">
-            <a:schemeClr val="accent1"/>
-          </a:effectRef>
-          <a:fontRef idx="minor">
-            <a:schemeClr val="lt1"/>
-          </a:fontRef>
-        </p:style>
-        <p:txBody>
-          <a:bodyPr rtlCol="0" anchor="ctr"/>
-          <a:lstStyle/>
-          <a:p>
-            <a:pPr algn="ctr"/>
-          </a:p>
-        </p:txBody>
-      </p:sp>
-      <p:sp>
-        <p:nvSpPr>
-          <p:cNvPr id="12" name="TextBox 11"/>
-          <p:cNvSpPr txBox="1"/>
-          <p:nvPr/>
-        </p:nvSpPr>
-        <p:spPr>
-          <a:xfrm>
-            <a:off x="960120" y="3328416"/>
-            <a:ext cx="10424160" cy="566928"/>
-          </a:xfrm>
-          <a:prstGeom prst="rect">
-            <a:avLst/>
-          </a:prstGeom>
-          <a:noFill/>
-        </p:spPr>
-        <p:txBody>
-          <a:bodyPr wrap="square">
-            <a:spAutoFit/>
-          </a:bodyPr>
-          <a:lstStyle/>
-          <a:p>
-            <a:pPr>
-              <a:defRPr sz="1600" b="0">
-                <a:solidFill>
-                  <a:srgbClr val="1E293B"/>
-                </a:solidFill>
-              </a:defRPr>
-            </a:pPr>
-            <a:r>
-              <a:t>No seat weeping at inlet; lifting lever free if equipped</a:t>
-            </a:r>
-          </a:p>
-        </p:txBody>
-      </p:sp>
-      <p:sp>
-        <p:nvSpPr>
-          <p:cNvPr id="13" name="Rectangle 12"/>
-          <p:cNvSpPr/>
-          <p:nvPr/>
-        </p:nvSpPr>
-        <p:spPr>
-          <a:xfrm>
-            <a:off x="685800" y="4059935"/>
-            <a:ext cx="164592" cy="164592"/>
-          </a:xfrm>
-          <a:prstGeom prst="rect">
-            <a:avLst/>
-          </a:prstGeom>
-          <a:solidFill>
-            <a:srgbClr val="B83A3A"/>
-          </a:solidFill>
-          <a:ln>
-            <a:noFill/>
-          </a:ln>
-        </p:spPr>
-        <p:style>
-          <a:lnRef idx="1">
-            <a:schemeClr val="accent1"/>
-          </a:lnRef>
-          <a:fillRef idx="3">
-            <a:schemeClr val="accent1"/>
-          </a:fillRef>
-          <a:effectRef idx="2">
-            <a:schemeClr val="accent1"/>
-          </a:effectRef>
-          <a:fontRef idx="minor">
-            <a:schemeClr val="lt1"/>
-          </a:fontRef>
-        </p:style>
-        <p:txBody>
-          <a:bodyPr rtlCol="0" anchor="ctr"/>
-          <a:lstStyle/>
-          <a:p>
-            <a:pPr algn="ctr"/>
-          </a:p>
-        </p:txBody>
-      </p:sp>
-      <p:sp>
-        <p:nvSpPr>
-          <p:cNvPr id="14" name="TextBox 13"/>
-          <p:cNvSpPr txBox="1"/>
-          <p:nvPr/>
-        </p:nvSpPr>
-        <p:spPr>
-          <a:xfrm>
-            <a:off x="960120" y="3986783"/>
-            <a:ext cx="10424160" cy="566928"/>
-          </a:xfrm>
-          <a:prstGeom prst="rect">
-            <a:avLst/>
-          </a:prstGeom>
-          <a:noFill/>
-        </p:spPr>
-        <p:txBody>
-          <a:bodyPr wrap="square">
-            <a:spAutoFit/>
-          </a:bodyPr>
-          <a:lstStyle/>
-          <a:p>
-            <a:pPr>
-              <a:defRPr sz="1600" b="0">
-                <a:solidFill>
-                  <a:srgbClr val="1E293B"/>
-                </a:solidFill>
-              </a:defRPr>
-            </a:pPr>
-            <a:r>
-              <a:t>Confirm valve not inadvertently isolated</a:t>
-            </a:r>
-          </a:p>
-        </p:txBody>
-      </p:sp>
-      <p:sp>
-        <p:nvSpPr>
-          <p:cNvPr id="15" name="Rectangle 14"/>
-          <p:cNvSpPr/>
-          <p:nvPr/>
-        </p:nvSpPr>
-        <p:spPr>
-          <a:xfrm>
-            <a:off x="685800" y="4718304"/>
-            <a:ext cx="164592" cy="164592"/>
-          </a:xfrm>
-          <a:prstGeom prst="rect">
-            <a:avLst/>
-          </a:prstGeom>
-          <a:solidFill>
-            <a:srgbClr val="B83A3A"/>
-          </a:solidFill>
-          <a:ln>
-            <a:noFill/>
-          </a:ln>
-        </p:spPr>
-        <p:style>
-          <a:lnRef idx="1">
-            <a:schemeClr val="accent1"/>
-          </a:lnRef>
-          <a:fillRef idx="3">
-            <a:schemeClr val="accent1"/>
-          </a:fillRef>
-          <a:effectRef idx="2">
-            <a:schemeClr val="accent1"/>
-          </a:effectRef>
-          <a:fontRef idx="minor">
-            <a:schemeClr val="lt1"/>
-          </a:fontRef>
-        </p:style>
-        <p:txBody>
-          <a:bodyPr rtlCol="0" anchor="ctr"/>
-          <a:lstStyle/>
-          <a:p>
-            <a:pPr algn="ctr"/>
-          </a:p>
-        </p:txBody>
-      </p:sp>
-      <p:sp>
-        <p:nvSpPr>
-          <p:cNvPr id="16" name="TextBox 15"/>
-          <p:cNvSpPr txBox="1"/>
-          <p:nvPr/>
-        </p:nvSpPr>
-        <p:spPr>
-          <a:xfrm>
-            <a:off x="960120" y="4645152"/>
-            <a:ext cx="10424160" cy="566928"/>
-          </a:xfrm>
-          <a:prstGeom prst="rect">
-            <a:avLst/>
-          </a:prstGeom>
-          <a:noFill/>
-        </p:spPr>
-        <p:txBody>
-          <a:bodyPr wrap="square">
-            <a:spAutoFit/>
-          </a:bodyPr>
-          <a:lstStyle/>
-          <a:p>
-            <a:pPr>
-              <a:defRPr sz="1600" b="0">
-                <a:solidFill>
-                  <a:srgbClr val="1E293B"/>
-                </a:solidFill>
-              </a:defRPr>
-            </a:pPr>
-            <a:r>
-              <a:t>Checklist completed before every removal or in-place test — filed in CMMS work order</a:t>
-            </a:r>
-          </a:p>
-        </p:txBody>
-      </p:sp>
-      <p:sp>
-        <p:nvSpPr>
-          <p:cNvPr id="17" name="Rectangle 16"/>
           <p:cNvSpPr/>
           <p:nvPr/>
         </p:nvSpPr>
@@ -7474,7 +8102,7 @@
       </p:sp>
       <p:sp>
         <p:nvSpPr>
-          <p:cNvPr id="18" name="TextBox 17"/>
+          <p:cNvPr id="8" name="TextBox 7"/>
           <p:cNvSpPr txBox="1"/>
           <p:nvPr/>
         </p:nvSpPr>
@@ -7502,7 +8130,7 @@
               </a:defRPr>
             </a:pPr>
             <a:r>
-              <a:t>Texas A&amp;M UES · Steam Safety Management Program</a:t>
+              <a:t>Maintenance Strategy · Section 4.1</a:t>
             </a:r>
           </a:p>
         </p:txBody>

</xml_diff>

<commit_message>
Regenerate PPT with 3-year replacement cycle slide
Co-authored-by: stavanparekh00-ai <stavanparekh00-ai@users.noreply.github.com>
</commit_message>
<xml_diff>
--- a/docs/presentation/UES-Steam-Safety-Program.pptx
+++ b/docs/presentation/UES-Steam-Safety-Program.pptx
@@ -32,6 +32,7 @@
     <p:sldId id="280" r:id="rId31"/>
     <p:sldId id="281" r:id="rId32"/>
     <p:sldId id="282" r:id="rId33"/>
+    <p:sldId id="283" r:id="rId34"/>
   </p:sldIdLst>
   <p:sldSz cx="12191695" cy="6858000" type="screen4x3"/>
   <p:notesSz cx="6858000" cy="9144000"/>
@@ -10572,7 +10573,7 @@
               </a:defRPr>
             </a:pPr>
             <a:r>
-              <a:t>Highest-Impact Program Improvements</a:t>
+              <a:t>3-Year Replacement Cycle by Location</a:t>
             </a:r>
           </a:p>
         </p:txBody>
@@ -10607,7 +10608,7 @@
               </a:defRPr>
             </a:pPr>
             <a:r>
-              <a:t>Section 5.5 — spare coverage is the single highest-impact improvement</a:t>
+              <a:t>Stagger replacements across sites so capital costs are predictable — not concentrated in one year</a:t>
             </a:r>
           </a:p>
         </p:txBody>
@@ -10657,23 +10658,78 @@
       </p:sp>
       <p:sp>
         <p:nvSpPr>
-          <p:cNvPr id="5" name="Rectangle 4"/>
+          <p:cNvPr id="5" name="TextBox 4"/>
+          <p:cNvSpPr txBox="1"/>
+          <p:nvPr/>
+        </p:nvSpPr>
+        <p:spPr>
+          <a:xfrm>
+            <a:off x="594360" y="1280160"/>
+            <a:ext cx="10972800" cy="960120"/>
+          </a:xfrm>
+          <a:prstGeom prst="rect">
+            <a:avLst/>
+          </a:prstGeom>
+          <a:noFill/>
+        </p:spPr>
+        <p:txBody>
+          <a:bodyPr wrap="square">
+            <a:spAutoFit/>
+          </a:bodyPr>
+          <a:lstStyle/>
+          <a:p>
+            <a:pPr>
+              <a:spcAft>
+                <a:spcPts val="400"/>
+              </a:spcAft>
+              <a:defRPr sz="1300" b="0">
+                <a:solidFill>
+                  <a:srgbClr val="1E293B"/>
+                </a:solidFill>
+              </a:defRPr>
+            </a:pPr>
+            <a:r>
+              <a:t>Without a rotation plan, valves installed together age out together — creating a single-year budget spike.</a:t>
+            </a:r>
+          </a:p>
+          <a:p>
+            <a:pPr>
+              <a:spcAft>
+                <a:spcPts val="400"/>
+              </a:spcAft>
+              <a:defRPr sz="1300" b="0">
+                <a:solidFill>
+                  <a:srgbClr val="1E293B"/>
+                </a:solidFill>
+              </a:defRPr>
+            </a:pPr>
+            <a:r>
+              <a:t>Assign each building or boiler location to a Year 1, 2, or 3 bucket so replacement and recert spend is level-loaded.</a:t>
+            </a:r>
+          </a:p>
+        </p:txBody>
+      </p:sp>
+      <p:sp>
+        <p:nvSpPr>
+          <p:cNvPr id="6" name="Rectangle 5"/>
           <p:cNvSpPr/>
           <p:nvPr/>
         </p:nvSpPr>
         <p:spPr>
           <a:xfrm>
-            <a:off x="685800" y="1508760"/>
-            <a:ext cx="128016" cy="128016"/>
+            <a:off x="594360" y="2377439"/>
+            <a:ext cx="3520440" cy="3246120"/>
           </a:xfrm>
           <a:prstGeom prst="rect">
             <a:avLst/>
           </a:prstGeom>
           <a:solidFill>
-            <a:srgbClr val="B83A3A"/>
+            <a:srgbClr val="FDF8F8"/>
           </a:solidFill>
           <a:ln>
-            <a:noFill/>
+            <a:solidFill>
+              <a:srgbClr val="B83A3A"/>
+            </a:solidFill>
           </a:ln>
         </p:spPr>
         <p:style>
@@ -10700,55 +10756,20 @@
       </p:sp>
       <p:sp>
         <p:nvSpPr>
-          <p:cNvPr id="6" name="TextBox 5"/>
-          <p:cNvSpPr txBox="1"/>
-          <p:nvPr/>
-        </p:nvSpPr>
-        <p:spPr>
-          <a:xfrm>
-            <a:off x="960120" y="1417319"/>
-            <a:ext cx="10515600" cy="731520"/>
-          </a:xfrm>
-          <a:prstGeom prst="rect">
-            <a:avLst/>
-          </a:prstGeom>
-          <a:noFill/>
-        </p:spPr>
-        <p:txBody>
-          <a:bodyPr wrap="square">
-            <a:spAutoFit/>
-          </a:bodyPr>
-          <a:lstStyle/>
-          <a:p>
-            <a:pPr>
-              <a:defRPr sz="1500" b="0">
-                <a:solidFill>
-                  <a:srgbClr val="1E293B"/>
-                </a:solidFill>
-              </a:defRPr>
-            </a:pPr>
-            <a:r>
-              <a:t>Acquire spares for valves with none — enables full bench testing</a:t>
-            </a:r>
-          </a:p>
-        </p:txBody>
-      </p:sp>
-      <p:sp>
-        <p:nvSpPr>
           <p:cNvPr id="7" name="Rectangle 6"/>
           <p:cNvSpPr/>
           <p:nvPr/>
         </p:nvSpPr>
         <p:spPr>
           <a:xfrm>
-            <a:off x="685800" y="2377440"/>
-            <a:ext cx="128016" cy="128016"/>
+            <a:off x="731520" y="2514599"/>
+            <a:ext cx="3246120" cy="384048"/>
           </a:xfrm>
           <a:prstGeom prst="rect">
             <a:avLst/>
           </a:prstGeom>
           <a:solidFill>
-            <a:srgbClr val="B83A3A"/>
+            <a:srgbClr val="500000"/>
           </a:solidFill>
           <a:ln>
             <a:noFill/>
@@ -10772,7 +10793,16 @@
           <a:bodyPr rtlCol="0" anchor="ctr"/>
           <a:lstStyle/>
           <a:p>
-            <a:pPr algn="ctr"/>
+            <a:pPr algn="ctr">
+              <a:defRPr sz="1400" b="1">
+                <a:solidFill>
+                  <a:srgbClr val="FFFFFF"/>
+                </a:solidFill>
+              </a:defRPr>
+            </a:pPr>
+            <a:r>
+              <a:t>Year 1</a:t>
+            </a:r>
           </a:p>
         </p:txBody>
       </p:sp>
@@ -10784,8 +10814,43 @@
         </p:nvSpPr>
         <p:spPr>
           <a:xfrm>
-            <a:off x="960120" y="2286000"/>
-            <a:ext cx="10515600" cy="731520"/>
+            <a:off x="731520" y="2971799"/>
+            <a:ext cx="3246120" cy="320040"/>
+          </a:xfrm>
+          <a:prstGeom prst="rect">
+            <a:avLst/>
+          </a:prstGeom>
+          <a:noFill/>
+        </p:spPr>
+        <p:txBody>
+          <a:bodyPr wrap="none">
+            <a:spAutoFit/>
+          </a:bodyPr>
+          <a:lstStyle/>
+          <a:p>
+            <a:pPr algn="ctr">
+              <a:defRPr sz="1200" b="1">
+                <a:solidFill>
+                  <a:srgbClr val="500000"/>
+                </a:solidFill>
+              </a:defRPr>
+            </a:pPr>
+            <a:r>
+              <a:t>Rotation group A</a:t>
+            </a:r>
+          </a:p>
+        </p:txBody>
+      </p:sp>
+      <p:sp>
+        <p:nvSpPr>
+          <p:cNvPr id="9" name="TextBox 8"/>
+          <p:cNvSpPr txBox="1"/>
+          <p:nvPr/>
+        </p:nvSpPr>
+        <p:spPr>
+          <a:xfrm>
+            <a:off x="777240" y="3337559"/>
+            <a:ext cx="3154680" cy="2103120"/>
           </a:xfrm>
           <a:prstGeom prst="rect">
             <a:avLst/>
@@ -10799,37 +10864,72 @@
           <a:lstStyle/>
           <a:p>
             <a:pPr>
-              <a:defRPr sz="1500" b="0">
+              <a:spcAft>
+                <a:spcPts val="500"/>
+              </a:spcAft>
+              <a:defRPr sz="1100" b="0">
                 <a:solidFill>
                   <a:srgbClr val="1E293B"/>
                 </a:solidFill>
               </a:defRPr>
             </a:pPr>
             <a:r>
-              <a:t>Rank valves by criticality to prioritize capital spend</a:t>
-            </a:r>
-          </a:p>
-        </p:txBody>
-      </p:sp>
-      <p:sp>
-        <p:nvSpPr>
-          <p:cNvPr id="9" name="Rectangle 8"/>
+              <a:t>• Assign ~⅓ of locations (by valve count)</a:t>
+            </a:r>
+          </a:p>
+          <a:p>
+            <a:pPr>
+              <a:spcAft>
+                <a:spcPts val="500"/>
+              </a:spcAft>
+              <a:defRPr sz="1100" b="0">
+                <a:solidFill>
+                  <a:srgbClr val="1E293B"/>
+                </a:solidFill>
+              </a:defRPr>
+            </a:pPr>
+            <a:r>
+              <a:t>• Commercial 150 psi replacements due this cycle</a:t>
+            </a:r>
+          </a:p>
+          <a:p>
+            <a:pPr>
+              <a:spcAft>
+                <a:spcPts val="500"/>
+              </a:spcAft>
+              <a:defRPr sz="1100" b="0">
+                <a:solidFill>
+                  <a:srgbClr val="1E293B"/>
+                </a:solidFill>
+              </a:defRPr>
+            </a:pPr>
+            <a:r>
+              <a:t>• Setpoint send-outs aligned to spare swaps</a:t>
+            </a:r>
+          </a:p>
+        </p:txBody>
+      </p:sp>
+      <p:sp>
+        <p:nvSpPr>
+          <p:cNvPr id="10" name="Rectangle 9"/>
           <p:cNvSpPr/>
           <p:nvPr/>
         </p:nvSpPr>
         <p:spPr>
           <a:xfrm>
-            <a:off x="685800" y="3246120"/>
-            <a:ext cx="128016" cy="128016"/>
+            <a:off x="4343400" y="2377439"/>
+            <a:ext cx="3520440" cy="3246120"/>
           </a:xfrm>
           <a:prstGeom prst="rect">
             <a:avLst/>
           </a:prstGeom>
           <a:solidFill>
-            <a:srgbClr val="B83A3A"/>
+            <a:srgbClr val="E0F2FE"/>
           </a:solidFill>
           <a:ln>
-            <a:noFill/>
+            <a:solidFill>
+              <a:srgbClr val="B83A3A"/>
+            </a:solidFill>
           </a:ln>
         </p:spPr>
         <p:style>
@@ -10856,55 +10956,20 @@
       </p:sp>
       <p:sp>
         <p:nvSpPr>
-          <p:cNvPr id="10" name="TextBox 9"/>
-          <p:cNvSpPr txBox="1"/>
-          <p:nvPr/>
-        </p:nvSpPr>
-        <p:spPr>
-          <a:xfrm>
-            <a:off x="960120" y="3154679"/>
-            <a:ext cx="10515600" cy="731520"/>
-          </a:xfrm>
-          <a:prstGeom prst="rect">
-            <a:avLst/>
-          </a:prstGeom>
-          <a:noFill/>
-        </p:spPr>
-        <p:txBody>
-          <a:bodyPr wrap="square">
-            <a:spAutoFit/>
-          </a:bodyPr>
-          <a:lstStyle/>
-          <a:p>
-            <a:pPr>
-              <a:defRPr sz="1500" b="0">
-                <a:solidFill>
-                  <a:srgbClr val="1E293B"/>
-                </a:solidFill>
-              </a:defRPr>
-            </a:pPr>
-            <a:r>
-              <a:t>Adopt semi-annual visual walkdowns as standard UES practice between formal tests</a:t>
-            </a:r>
-          </a:p>
-        </p:txBody>
-      </p:sp>
-      <p:sp>
-        <p:nvSpPr>
           <p:cNvPr id="11" name="Rectangle 10"/>
           <p:cNvSpPr/>
           <p:nvPr/>
         </p:nvSpPr>
         <p:spPr>
           <a:xfrm>
-            <a:off x="685800" y="4114799"/>
-            <a:ext cx="128016" cy="128016"/>
+            <a:off x="4480560" y="2514599"/>
+            <a:ext cx="3246120" cy="384048"/>
           </a:xfrm>
           <a:prstGeom prst="rect">
             <a:avLst/>
           </a:prstGeom>
           <a:solidFill>
-            <a:srgbClr val="B83A3A"/>
+            <a:srgbClr val="500000"/>
           </a:solidFill>
           <a:ln>
             <a:noFill/>
@@ -10928,7 +10993,16 @@
           <a:bodyPr rtlCol="0" anchor="ctr"/>
           <a:lstStyle/>
           <a:p>
-            <a:pPr algn="ctr"/>
+            <a:pPr algn="ctr">
+              <a:defRPr sz="1400" b="1">
+                <a:solidFill>
+                  <a:srgbClr val="FFFFFF"/>
+                </a:solidFill>
+              </a:defRPr>
+            </a:pPr>
+            <a:r>
+              <a:t>Year 2</a:t>
+            </a:r>
           </a:p>
         </p:txBody>
       </p:sp>
@@ -10940,8 +11014,43 @@
         </p:nvSpPr>
         <p:spPr>
           <a:xfrm>
-            <a:off x="960120" y="4023359"/>
-            <a:ext cx="10515600" cy="731520"/>
+            <a:off x="4480560" y="2971799"/>
+            <a:ext cx="3246120" cy="320040"/>
+          </a:xfrm>
+          <a:prstGeom prst="rect">
+            <a:avLst/>
+          </a:prstGeom>
+          <a:noFill/>
+        </p:spPr>
+        <p:txBody>
+          <a:bodyPr wrap="none">
+            <a:spAutoFit/>
+          </a:bodyPr>
+          <a:lstStyle/>
+          <a:p>
+            <a:pPr algn="ctr">
+              <a:defRPr sz="1200" b="1">
+                <a:solidFill>
+                  <a:srgbClr val="500000"/>
+                </a:solidFill>
+              </a:defRPr>
+            </a:pPr>
+            <a:r>
+              <a:t>Rotation group B</a:t>
+            </a:r>
+          </a:p>
+        </p:txBody>
+      </p:sp>
+      <p:sp>
+        <p:nvSpPr>
+          <p:cNvPr id="13" name="TextBox 12"/>
+          <p:cNvSpPr txBox="1"/>
+          <p:nvPr/>
+        </p:nvSpPr>
+        <p:spPr>
+          <a:xfrm>
+            <a:off x="4526280" y="3337559"/>
+            <a:ext cx="3154680" cy="2103120"/>
           </a:xfrm>
           <a:prstGeom prst="rect">
             <a:avLst/>
@@ -10955,37 +11064,72 @@
           <a:lstStyle/>
           <a:p>
             <a:pPr>
-              <a:defRPr sz="1500" b="0">
+              <a:spcAft>
+                <a:spcPts val="500"/>
+              </a:spcAft>
+              <a:defRPr sz="1100" b="0">
                 <a:solidFill>
                   <a:srgbClr val="1E293B"/>
                 </a:solidFill>
               </a:defRPr>
             </a:pPr>
             <a:r>
-              <a:t>Keep dashboard and master register as the single source of truth</a:t>
-            </a:r>
-          </a:p>
-        </p:txBody>
-      </p:sp>
-      <p:sp>
-        <p:nvSpPr>
-          <p:cNvPr id="13" name="Rectangle 12"/>
+              <a:t>• Next third of campus / plant locations</a:t>
+            </a:r>
+          </a:p>
+          <a:p>
+            <a:pPr>
+              <a:spcAft>
+                <a:spcPts val="500"/>
+              </a:spcAft>
+              <a:defRPr sz="1100" b="0">
+                <a:solidFill>
+                  <a:srgbClr val="1E293B"/>
+                </a:solidFill>
+              </a:defRPr>
+            </a:pPr>
+            <a:r>
+              <a:t>• Balance workload with Year 1 completions</a:t>
+            </a:r>
+          </a:p>
+          <a:p>
+            <a:pPr>
+              <a:spcAft>
+                <a:spcPts val="500"/>
+              </a:spcAft>
+              <a:defRPr sz="1100" b="0">
+                <a:solidFill>
+                  <a:srgbClr val="1E293B"/>
+                </a:solidFill>
+              </a:defRPr>
+            </a:pPr>
+            <a:r>
+              <a:t>• Update dashboard due dates after each swap</a:t>
+            </a:r>
+          </a:p>
+        </p:txBody>
+      </p:sp>
+      <p:sp>
+        <p:nvSpPr>
+          <p:cNvPr id="14" name="Rectangle 13"/>
           <p:cNvSpPr/>
           <p:nvPr/>
         </p:nvSpPr>
         <p:spPr>
           <a:xfrm>
-            <a:off x="685800" y="4983479"/>
-            <a:ext cx="128016" cy="128016"/>
+            <a:off x="8092440" y="2377439"/>
+            <a:ext cx="3520440" cy="3246120"/>
           </a:xfrm>
           <a:prstGeom prst="rect">
             <a:avLst/>
           </a:prstGeom>
           <a:solidFill>
-            <a:srgbClr val="B83A3A"/>
+            <a:srgbClr val="ECFDF5"/>
           </a:solidFill>
           <a:ln>
-            <a:noFill/>
+            <a:solidFill>
+              <a:srgbClr val="B83A3A"/>
+            </a:solidFill>
           </a:ln>
         </p:spPr>
         <p:style>
@@ -11012,14 +11156,101 @@
       </p:sp>
       <p:sp>
         <p:nvSpPr>
-          <p:cNvPr id="14" name="TextBox 13"/>
+          <p:cNvPr id="15" name="Rectangle 14"/>
+          <p:cNvSpPr/>
+          <p:nvPr/>
+        </p:nvSpPr>
+        <p:spPr>
+          <a:xfrm>
+            <a:off x="8229600" y="2514599"/>
+            <a:ext cx="3246120" cy="384048"/>
+          </a:xfrm>
+          <a:prstGeom prst="rect">
+            <a:avLst/>
+          </a:prstGeom>
+          <a:solidFill>
+            <a:srgbClr val="500000"/>
+          </a:solidFill>
+          <a:ln>
+            <a:noFill/>
+          </a:ln>
+        </p:spPr>
+        <p:style>
+          <a:lnRef idx="1">
+            <a:schemeClr val="accent1"/>
+          </a:lnRef>
+          <a:fillRef idx="3">
+            <a:schemeClr val="accent1"/>
+          </a:fillRef>
+          <a:effectRef idx="2">
+            <a:schemeClr val="accent1"/>
+          </a:effectRef>
+          <a:fontRef idx="minor">
+            <a:schemeClr val="lt1"/>
+          </a:fontRef>
+        </p:style>
+        <p:txBody>
+          <a:bodyPr rtlCol="0" anchor="ctr"/>
+          <a:lstStyle/>
+          <a:p>
+            <a:pPr algn="ctr">
+              <a:defRPr sz="1400" b="1">
+                <a:solidFill>
+                  <a:srgbClr val="FFFFFF"/>
+                </a:solidFill>
+              </a:defRPr>
+            </a:pPr>
+            <a:r>
+              <a:t>Year 3</a:t>
+            </a:r>
+          </a:p>
+        </p:txBody>
+      </p:sp>
+      <p:sp>
+        <p:nvSpPr>
+          <p:cNvPr id="16" name="TextBox 15"/>
           <p:cNvSpPr txBox="1"/>
           <p:nvPr/>
         </p:nvSpPr>
         <p:spPr>
           <a:xfrm>
-            <a:off x="960120" y="4892040"/>
-            <a:ext cx="10515600" cy="731520"/>
+            <a:off x="8229600" y="2971799"/>
+            <a:ext cx="3246120" cy="320040"/>
+          </a:xfrm>
+          <a:prstGeom prst="rect">
+            <a:avLst/>
+          </a:prstGeom>
+          <a:noFill/>
+        </p:spPr>
+        <p:txBody>
+          <a:bodyPr wrap="none">
+            <a:spAutoFit/>
+          </a:bodyPr>
+          <a:lstStyle/>
+          <a:p>
+            <a:pPr algn="ctr">
+              <a:defRPr sz="1200" b="1">
+                <a:solidFill>
+                  <a:srgbClr val="500000"/>
+                </a:solidFill>
+              </a:defRPr>
+            </a:pPr>
+            <a:r>
+              <a:t>Rotation group C</a:t>
+            </a:r>
+          </a:p>
+        </p:txBody>
+      </p:sp>
+      <p:sp>
+        <p:nvSpPr>
+          <p:cNvPr id="17" name="TextBox 16"/>
+          <p:cNvSpPr txBox="1"/>
+          <p:nvPr/>
+        </p:nvSpPr>
+        <p:spPr>
+          <a:xfrm>
+            <a:off x="8275319" y="3337559"/>
+            <a:ext cx="3154680" cy="2103120"/>
           </a:xfrm>
           <a:prstGeom prst="rect">
             <a:avLst/>
@@ -11033,21 +11264,108 @@
           <a:lstStyle/>
           <a:p>
             <a:pPr>
-              <a:defRPr sz="1500" b="0">
+              <a:spcAft>
+                <a:spcPts val="500"/>
+              </a:spcAft>
+              <a:defRPr sz="1100" b="0">
                 <a:solidFill>
                   <a:srgbClr val="1E293B"/>
                 </a:solidFill>
               </a:defRPr>
             </a:pPr>
             <a:r>
-              <a:t>Management decision needed on routine manual lever testing — risk vs. PG-73.1.3 compliance</a:t>
-            </a:r>
-          </a:p>
-        </p:txBody>
-      </p:sp>
-      <p:sp>
-        <p:nvSpPr>
-          <p:cNvPr id="15" name="TextBox 14"/>
+              <a:t>• Remaining locations complete the cycle</a:t>
+            </a:r>
+          </a:p>
+          <a:p>
+            <a:pPr>
+              <a:spcAft>
+                <a:spcPts val="500"/>
+              </a:spcAft>
+              <a:defRPr sz="1100" b="0">
+                <a:solidFill>
+                  <a:srgbClr val="1E293B"/>
+                </a:solidFill>
+              </a:defRPr>
+            </a:pPr>
+            <a:r>
+              <a:t>• Cycle restarts — locations return to Year 1</a:t>
+            </a:r>
+          </a:p>
+          <a:p>
+            <a:pPr>
+              <a:spcAft>
+                <a:spcPts val="500"/>
+              </a:spcAft>
+              <a:defRPr sz="1100" b="0">
+                <a:solidFill>
+                  <a:srgbClr val="1E293B"/>
+                </a:solidFill>
+              </a:defRPr>
+            </a:pPr>
+            <a:r>
+              <a:t>• One due-date logic across the whole fleet</a:t>
+            </a:r>
+          </a:p>
+        </p:txBody>
+      </p:sp>
+      <p:sp>
+        <p:nvSpPr>
+          <p:cNvPr id="18" name="Rectangle 17"/>
+          <p:cNvSpPr/>
+          <p:nvPr/>
+        </p:nvSpPr>
+        <p:spPr>
+          <a:xfrm>
+            <a:off x="594360" y="5806440"/>
+            <a:ext cx="10972800" cy="685800"/>
+          </a:xfrm>
+          <a:prstGeom prst="rect">
+            <a:avLst/>
+          </a:prstGeom>
+          <a:solidFill>
+            <a:srgbClr val="FFFBEB"/>
+          </a:solidFill>
+          <a:ln>
+            <a:solidFill>
+              <a:srgbClr val="B83A3A"/>
+            </a:solidFill>
+          </a:ln>
+        </p:spPr>
+        <p:style>
+          <a:lnRef idx="1">
+            <a:schemeClr val="accent1"/>
+          </a:lnRef>
+          <a:fillRef idx="3">
+            <a:schemeClr val="accent1"/>
+          </a:fillRef>
+          <a:effectRef idx="2">
+            <a:schemeClr val="accent1"/>
+          </a:effectRef>
+          <a:fontRef idx="minor">
+            <a:schemeClr val="lt1"/>
+          </a:fontRef>
+        </p:style>
+        <p:txBody>
+          <a:bodyPr rtlCol="0" anchor="ctr" wrap="square"/>
+          <a:lstStyle/>
+          <a:p>
+            <a:pPr algn="ctr">
+              <a:defRPr sz="1100" b="1">
+                <a:solidFill>
+                  <a:srgbClr val="1E293B"/>
+                </a:solidFill>
+              </a:defRPr>
+            </a:pPr>
+            <a:r>
+              <a:t>How to build the plan: use dashboard valve counts and due dates per location · prioritize failed annual lever tests and overdue recerts into the nearest rotation year · leadership approves a 3-year capital forecast (~⅓ of fleet cost per year)</a:t>
+            </a:r>
+          </a:p>
+        </p:txBody>
+      </p:sp>
+      <p:sp>
+        <p:nvSpPr>
+          <p:cNvPr id="19" name="TextBox 18"/>
           <p:cNvSpPr txBox="1"/>
           <p:nvPr/>
         </p:nvSpPr>
@@ -11136,20 +11454,55 @@
               </a:defRPr>
             </a:pPr>
             <a:r>
-              <a:t>Program Outcomes &amp; Value Delivered</a:t>
-            </a:r>
-          </a:p>
-        </p:txBody>
-      </p:sp>
-      <p:sp>
-        <p:nvSpPr>
-          <p:cNvPr id="3" name="Rectangle 2"/>
+              <a:t>Highest-Impact Program Improvements</a:t>
+            </a:r>
+          </a:p>
+        </p:txBody>
+      </p:sp>
+      <p:sp>
+        <p:nvSpPr>
+          <p:cNvPr id="3" name="TextBox 2"/>
+          <p:cNvSpPr txBox="1"/>
+          <p:nvPr/>
+        </p:nvSpPr>
+        <p:spPr>
+          <a:xfrm>
+            <a:off x="594360" y="822960"/>
+            <a:ext cx="11064240" cy="347472"/>
+          </a:xfrm>
+          <a:prstGeom prst="rect">
+            <a:avLst/>
+          </a:prstGeom>
+          <a:noFill/>
+        </p:spPr>
+        <p:txBody>
+          <a:bodyPr wrap="none">
+            <a:spAutoFit/>
+          </a:bodyPr>
+          <a:lstStyle/>
+          <a:p>
+            <a:pPr>
+              <a:defRPr sz="1300" b="0">
+                <a:solidFill>
+                  <a:srgbClr val="64748B"/>
+                </a:solidFill>
+              </a:defRPr>
+            </a:pPr>
+            <a:r>
+              <a:t>Section 5.5 — spare coverage is the single highest-impact improvement</a:t>
+            </a:r>
+          </a:p>
+        </p:txBody>
+      </p:sp>
+      <p:sp>
+        <p:nvSpPr>
+          <p:cNvPr id="4" name="Rectangle 3"/>
           <p:cNvSpPr/>
           <p:nvPr/>
         </p:nvSpPr>
         <p:spPr>
           <a:xfrm>
-            <a:off x="594360" y="932688"/>
+            <a:off x="594360" y="1170432"/>
             <a:ext cx="10972800" cy="36576"/>
           </a:xfrm>
           <a:prstGeom prst="rect">
@@ -11186,25 +11539,23 @@
       </p:sp>
       <p:sp>
         <p:nvSpPr>
-          <p:cNvPr id="4" name="Rectangle 3"/>
+          <p:cNvPr id="5" name="Rectangle 4"/>
           <p:cNvSpPr/>
           <p:nvPr/>
         </p:nvSpPr>
         <p:spPr>
           <a:xfrm>
-            <a:off x="594360" y="1042416"/>
-            <a:ext cx="5440680" cy="5074920"/>
+            <a:off x="685800" y="1508760"/>
+            <a:ext cx="128016" cy="128016"/>
           </a:xfrm>
           <a:prstGeom prst="rect">
             <a:avLst/>
           </a:prstGeom>
           <a:solidFill>
-            <a:srgbClr val="FDF8F8"/>
+            <a:srgbClr val="B83A3A"/>
           </a:solidFill>
           <a:ln>
-            <a:solidFill>
-              <a:srgbClr val="B83A3A"/>
-            </a:solidFill>
+            <a:noFill/>
           </a:ln>
         </p:spPr>
         <p:style>
@@ -11231,49 +11582,14 @@
       </p:sp>
       <p:sp>
         <p:nvSpPr>
-          <p:cNvPr id="5" name="TextBox 4"/>
-          <p:cNvSpPr txBox="1"/>
-          <p:nvPr/>
-        </p:nvSpPr>
-        <p:spPr>
-          <a:xfrm>
-            <a:off x="777240" y="1179576"/>
-            <a:ext cx="5029200" cy="320040"/>
-          </a:xfrm>
-          <a:prstGeom prst="rect">
-            <a:avLst/>
-          </a:prstGeom>
-          <a:noFill/>
-        </p:spPr>
-        <p:txBody>
-          <a:bodyPr wrap="none">
-            <a:spAutoFit/>
-          </a:bodyPr>
-          <a:lstStyle/>
-          <a:p>
-            <a:pPr>
-              <a:defRPr sz="1500" b="1">
-                <a:solidFill>
-                  <a:srgbClr val="500000"/>
-                </a:solidFill>
-              </a:defRPr>
-            </a:pPr>
-            <a:r>
-              <a:t>Operational value</a:t>
-            </a:r>
-          </a:p>
-        </p:txBody>
-      </p:sp>
-      <p:sp>
-        <p:nvSpPr>
           <p:cNvPr id="6" name="TextBox 5"/>
           <p:cNvSpPr txBox="1"/>
           <p:nvPr/>
         </p:nvSpPr>
         <p:spPr>
           <a:xfrm>
-            <a:off x="822960" y="1545336"/>
-            <a:ext cx="4983480" cy="4389120"/>
+            <a:off x="960120" y="1417319"/>
+            <a:ext cx="10515600" cy="731520"/>
           </a:xfrm>
           <a:prstGeom prst="rect">
             <a:avLst/>
@@ -11287,77 +11603,14 @@
           <a:lstStyle/>
           <a:p>
             <a:pPr>
-              <a:spcAft>
-                <a:spcPts val="800"/>
-              </a:spcAft>
-              <a:defRPr sz="1400" b="0">
+              <a:defRPr sz="1500" b="0">
                 <a:solidFill>
                   <a:srgbClr val="1E293B"/>
                 </a:solidFill>
               </a:defRPr>
             </a:pPr>
             <a:r>
-              <a:t>• Complete valve inventory across steam systems</a:t>
-            </a:r>
-          </a:p>
-          <a:p>
-            <a:pPr>
-              <a:spcAft>
-                <a:spcPts val="800"/>
-              </a:spcAft>
-              <a:defRPr sz="1400" b="0">
-                <a:solidFill>
-                  <a:srgbClr val="1E293B"/>
-                </a:solidFill>
-              </a:defRPr>
-            </a:pPr>
-            <a:r>
-              <a:t>• Visible compliance status by equipment and site</a:t>
-            </a:r>
-          </a:p>
-          <a:p>
-            <a:pPr>
-              <a:spcAft>
-                <a:spcPts val="800"/>
-              </a:spcAft>
-              <a:defRPr sz="1400" b="0">
-                <a:solidFill>
-                  <a:srgbClr val="1E293B"/>
-                </a:solidFill>
-              </a:defRPr>
-            </a:pPr>
-            <a:r>
-              <a:t>• Traceable history for audits and incidents</a:t>
-            </a:r>
-          </a:p>
-          <a:p>
-            <a:pPr>
-              <a:spcAft>
-                <a:spcPts val="800"/>
-              </a:spcAft>
-              <a:defRPr sz="1400" b="0">
-                <a:solidFill>
-                  <a:srgbClr val="1E293B"/>
-                </a:solidFill>
-              </a:defRPr>
-            </a:pPr>
-            <a:r>
-              <a:t>• Faster planning for Setpoint outages and swaps</a:t>
-            </a:r>
-          </a:p>
-          <a:p>
-            <a:pPr>
-              <a:spcAft>
-                <a:spcPts val="800"/>
-              </a:spcAft>
-              <a:defRPr sz="1400" b="0">
-                <a:solidFill>
-                  <a:srgbClr val="1E293B"/>
-                </a:solidFill>
-              </a:defRPr>
-            </a:pPr>
-            <a:r>
-              <a:t>• Reduced reliance on memory and scattered files</a:t>
+              <a:t>Acquire spares for valves with none — enables full bench testing</a:t>
             </a:r>
           </a:p>
         </p:txBody>
@@ -11370,19 +11623,17 @@
         </p:nvSpPr>
         <p:spPr>
           <a:xfrm>
-            <a:off x="6172200" y="1042416"/>
-            <a:ext cx="5440680" cy="5074920"/>
+            <a:off x="685800" y="2377440"/>
+            <a:ext cx="128016" cy="128016"/>
           </a:xfrm>
           <a:prstGeom prst="rect">
             <a:avLst/>
           </a:prstGeom>
           <a:solidFill>
-            <a:srgbClr val="E0F2FE"/>
+            <a:srgbClr val="B83A3A"/>
           </a:solidFill>
           <a:ln>
-            <a:solidFill>
-              <a:srgbClr val="B83A3A"/>
-            </a:solidFill>
+            <a:noFill/>
           </a:ln>
         </p:spPr>
         <p:style>
@@ -11415,43 +11666,8 @@
         </p:nvSpPr>
         <p:spPr>
           <a:xfrm>
-            <a:off x="6355080" y="1179576"/>
-            <a:ext cx="5029200" cy="320040"/>
-          </a:xfrm>
-          <a:prstGeom prst="rect">
-            <a:avLst/>
-          </a:prstGeom>
-          <a:noFill/>
-        </p:spPr>
-        <p:txBody>
-          <a:bodyPr wrap="none">
-            <a:spAutoFit/>
-          </a:bodyPr>
-          <a:lstStyle/>
-          <a:p>
-            <a:pPr>
-              <a:defRPr sz="1500" b="1">
-                <a:solidFill>
-                  <a:srgbClr val="500000"/>
-                </a:solidFill>
-              </a:defRPr>
-            </a:pPr>
-            <a:r>
-              <a:t>Strategic value</a:t>
-            </a:r>
-          </a:p>
-        </p:txBody>
-      </p:sp>
-      <p:sp>
-        <p:nvSpPr>
-          <p:cNvPr id="9" name="TextBox 8"/>
-          <p:cNvSpPr txBox="1"/>
-          <p:nvPr/>
-        </p:nvSpPr>
-        <p:spPr>
-          <a:xfrm>
-            <a:off x="6400800" y="1545336"/>
-            <a:ext cx="4983480" cy="4389120"/>
+            <a:off x="960120" y="2286000"/>
+            <a:ext cx="10515600" cy="731520"/>
           </a:xfrm>
           <a:prstGeom prst="rect">
             <a:avLst/>
@@ -11465,84 +11681,255 @@
           <a:lstStyle/>
           <a:p>
             <a:pPr>
-              <a:spcAft>
-                <a:spcPts val="800"/>
-              </a:spcAft>
-              <a:defRPr sz="1400" b="0">
+              <a:defRPr sz="1500" b="0">
                 <a:solidFill>
                   <a:srgbClr val="1E293B"/>
                 </a:solidFill>
               </a:defRPr>
             </a:pPr>
             <a:r>
-              <a:t>• Code-aligned maintenance strategy document</a:t>
-            </a:r>
-          </a:p>
+              <a:t>Rank valves by criticality to prioritize capital spend</a:t>
+            </a:r>
+          </a:p>
+        </p:txBody>
+      </p:sp>
+      <p:sp>
+        <p:nvSpPr>
+          <p:cNvPr id="9" name="Rectangle 8"/>
+          <p:cNvSpPr/>
+          <p:nvPr/>
+        </p:nvSpPr>
+        <p:spPr>
+          <a:xfrm>
+            <a:off x="685800" y="3246120"/>
+            <a:ext cx="128016" cy="128016"/>
+          </a:xfrm>
+          <a:prstGeom prst="rect">
+            <a:avLst/>
+          </a:prstGeom>
+          <a:solidFill>
+            <a:srgbClr val="B83A3A"/>
+          </a:solidFill>
+          <a:ln>
+            <a:noFill/>
+          </a:ln>
+        </p:spPr>
+        <p:style>
+          <a:lnRef idx="1">
+            <a:schemeClr val="accent1"/>
+          </a:lnRef>
+          <a:fillRef idx="3">
+            <a:schemeClr val="accent1"/>
+          </a:fillRef>
+          <a:effectRef idx="2">
+            <a:schemeClr val="accent1"/>
+          </a:effectRef>
+          <a:fontRef idx="minor">
+            <a:schemeClr val="lt1"/>
+          </a:fontRef>
+        </p:style>
+        <p:txBody>
+          <a:bodyPr rtlCol="0" anchor="ctr"/>
+          <a:lstStyle/>
+          <a:p>
+            <a:pPr algn="ctr"/>
+          </a:p>
+        </p:txBody>
+      </p:sp>
+      <p:sp>
+        <p:nvSpPr>
+          <p:cNvPr id="10" name="TextBox 9"/>
+          <p:cNvSpPr txBox="1"/>
+          <p:nvPr/>
+        </p:nvSpPr>
+        <p:spPr>
+          <a:xfrm>
+            <a:off x="960120" y="3154679"/>
+            <a:ext cx="10515600" cy="731520"/>
+          </a:xfrm>
+          <a:prstGeom prst="rect">
+            <a:avLst/>
+          </a:prstGeom>
+          <a:noFill/>
+        </p:spPr>
+        <p:txBody>
+          <a:bodyPr wrap="square">
+            <a:spAutoFit/>
+          </a:bodyPr>
+          <a:lstStyle/>
           <a:p>
             <a:pPr>
-              <a:spcAft>
-                <a:spcPts val="800"/>
-              </a:spcAft>
-              <a:defRPr sz="1400" b="0">
+              <a:defRPr sz="1500" b="0">
                 <a:solidFill>
                   <a:srgbClr val="1E293B"/>
                 </a:solidFill>
               </a:defRPr>
             </a:pPr>
             <a:r>
-              <a:t>• Foundation for CMMS integration and spare pooling</a:t>
-            </a:r>
-          </a:p>
+              <a:t>Adopt semi-annual visual walkdowns as standard UES practice between formal tests</a:t>
+            </a:r>
+          </a:p>
+        </p:txBody>
+      </p:sp>
+      <p:sp>
+        <p:nvSpPr>
+          <p:cNvPr id="11" name="Rectangle 10"/>
+          <p:cNvSpPr/>
+          <p:nvPr/>
+        </p:nvSpPr>
+        <p:spPr>
+          <a:xfrm>
+            <a:off x="685800" y="4114799"/>
+            <a:ext cx="128016" cy="128016"/>
+          </a:xfrm>
+          <a:prstGeom prst="rect">
+            <a:avLst/>
+          </a:prstGeom>
+          <a:solidFill>
+            <a:srgbClr val="B83A3A"/>
+          </a:solidFill>
+          <a:ln>
+            <a:noFill/>
+          </a:ln>
+        </p:spPr>
+        <p:style>
+          <a:lnRef idx="1">
+            <a:schemeClr val="accent1"/>
+          </a:lnRef>
+          <a:fillRef idx="3">
+            <a:schemeClr val="accent1"/>
+          </a:fillRef>
+          <a:effectRef idx="2">
+            <a:schemeClr val="accent1"/>
+          </a:effectRef>
+          <a:fontRef idx="minor">
+            <a:schemeClr val="lt1"/>
+          </a:fontRef>
+        </p:style>
+        <p:txBody>
+          <a:bodyPr rtlCol="0" anchor="ctr"/>
+          <a:lstStyle/>
+          <a:p>
+            <a:pPr algn="ctr"/>
+          </a:p>
+        </p:txBody>
+      </p:sp>
+      <p:sp>
+        <p:nvSpPr>
+          <p:cNvPr id="12" name="TextBox 11"/>
+          <p:cNvSpPr txBox="1"/>
+          <p:nvPr/>
+        </p:nvSpPr>
+        <p:spPr>
+          <a:xfrm>
+            <a:off x="960120" y="4023359"/>
+            <a:ext cx="10515600" cy="731520"/>
+          </a:xfrm>
+          <a:prstGeom prst="rect">
+            <a:avLst/>
+          </a:prstGeom>
+          <a:noFill/>
+        </p:spPr>
+        <p:txBody>
+          <a:bodyPr wrap="square">
+            <a:spAutoFit/>
+          </a:bodyPr>
+          <a:lstStyle/>
           <a:p>
             <a:pPr>
-              <a:spcAft>
-                <a:spcPts val="800"/>
-              </a:spcAft>
-              <a:defRPr sz="1400" b="0">
+              <a:defRPr sz="1500" b="0">
                 <a:solidFill>
                   <a:srgbClr val="1E293B"/>
                 </a:solidFill>
               </a:defRPr>
             </a:pPr>
             <a:r>
-              <a:t>• Data to support capital requests for spares</a:t>
-            </a:r>
-          </a:p>
+              <a:t>Keep dashboard and master register as the single source of truth</a:t>
+            </a:r>
+          </a:p>
+        </p:txBody>
+      </p:sp>
+      <p:sp>
+        <p:nvSpPr>
+          <p:cNvPr id="13" name="Rectangle 12"/>
+          <p:cNvSpPr/>
+          <p:nvPr/>
+        </p:nvSpPr>
+        <p:spPr>
+          <a:xfrm>
+            <a:off x="685800" y="4983479"/>
+            <a:ext cx="128016" cy="128016"/>
+          </a:xfrm>
+          <a:prstGeom prst="rect">
+            <a:avLst/>
+          </a:prstGeom>
+          <a:solidFill>
+            <a:srgbClr val="B83A3A"/>
+          </a:solidFill>
+          <a:ln>
+            <a:noFill/>
+          </a:ln>
+        </p:spPr>
+        <p:style>
+          <a:lnRef idx="1">
+            <a:schemeClr val="accent1"/>
+          </a:lnRef>
+          <a:fillRef idx="3">
+            <a:schemeClr val="accent1"/>
+          </a:fillRef>
+          <a:effectRef idx="2">
+            <a:schemeClr val="accent1"/>
+          </a:effectRef>
+          <a:fontRef idx="minor">
+            <a:schemeClr val="lt1"/>
+          </a:fontRef>
+        </p:style>
+        <p:txBody>
+          <a:bodyPr rtlCol="0" anchor="ctr"/>
+          <a:lstStyle/>
+          <a:p>
+            <a:pPr algn="ctr"/>
+          </a:p>
+        </p:txBody>
+      </p:sp>
+      <p:sp>
+        <p:nvSpPr>
+          <p:cNvPr id="14" name="TextBox 13"/>
+          <p:cNvSpPr txBox="1"/>
+          <p:nvPr/>
+        </p:nvSpPr>
+        <p:spPr>
+          <a:xfrm>
+            <a:off x="960120" y="4892040"/>
+            <a:ext cx="10515600" cy="731520"/>
+          </a:xfrm>
+          <a:prstGeom prst="rect">
+            <a:avLst/>
+          </a:prstGeom>
+          <a:noFill/>
+        </p:spPr>
+        <p:txBody>
+          <a:bodyPr wrap="square">
+            <a:spAutoFit/>
+          </a:bodyPr>
+          <a:lstStyle/>
           <a:p>
             <a:pPr>
-              <a:spcAft>
-                <a:spcPts val="800"/>
-              </a:spcAft>
-              <a:defRPr sz="1400" b="0">
+              <a:defRPr sz="1500" b="0">
                 <a:solidFill>
                   <a:srgbClr val="1E293B"/>
                 </a:solidFill>
               </a:defRPr>
             </a:pPr>
             <a:r>
-              <a:t>• Leadership-ready reporting via dashboard &amp; Excel</a:t>
-            </a:r>
-          </a:p>
-          <a:p>
-            <a:pPr>
-              <a:spcAft>
-                <a:spcPts val="800"/>
-              </a:spcAft>
-              <a:defRPr sz="1400" b="0">
-                <a:solidFill>
-                  <a:srgbClr val="1E293B"/>
-                </a:solidFill>
-              </a:defRPr>
-            </a:pPr>
-            <a:r>
-              <a:t>• Sustainable program ownership within UES</a:t>
-            </a:r>
-          </a:p>
-        </p:txBody>
-      </p:sp>
-      <p:sp>
-        <p:nvSpPr>
-          <p:cNvPr id="10" name="TextBox 9"/>
+              <a:t>Management decision needed on routine manual lever testing — risk vs. PG-73.1.3 compliance</a:t>
+            </a:r>
+          </a:p>
+        </p:txBody>
+      </p:sp>
+      <p:sp>
+        <p:nvSpPr>
+          <p:cNvPr id="15" name="TextBox 14"/>
           <p:cNvSpPr txBox="1"/>
           <p:nvPr/>
         </p:nvSpPr>
@@ -11631,55 +12018,20 @@
               </a:defRPr>
             </a:pPr>
             <a:r>
-              <a:t>Recommended Next Steps</a:t>
-            </a:r>
-          </a:p>
-        </p:txBody>
-      </p:sp>
-      <p:sp>
-        <p:nvSpPr>
-          <p:cNvPr id="3" name="TextBox 2"/>
-          <p:cNvSpPr txBox="1"/>
-          <p:nvPr/>
-        </p:nvSpPr>
-        <p:spPr>
-          <a:xfrm>
-            <a:off x="594360" y="822960"/>
-            <a:ext cx="11064240" cy="347472"/>
-          </a:xfrm>
-          <a:prstGeom prst="rect">
-            <a:avLst/>
-          </a:prstGeom>
-          <a:noFill/>
-        </p:spPr>
-        <p:txBody>
-          <a:bodyPr wrap="none">
-            <a:spAutoFit/>
-          </a:bodyPr>
-          <a:lstStyle/>
-          <a:p>
-            <a:pPr>
-              <a:defRPr sz="1300" b="0">
-                <a:solidFill>
-                  <a:srgbClr val="64748B"/>
-                </a:solidFill>
-              </a:defRPr>
-            </a:pPr>
-            <a:r>
-              <a:t>Leadership decisions to sustain the program</a:t>
-            </a:r>
-          </a:p>
-        </p:txBody>
-      </p:sp>
-      <p:sp>
-        <p:nvSpPr>
-          <p:cNvPr id="4" name="Rectangle 3"/>
+              <a:t>Program Outcomes &amp; Value Delivered</a:t>
+            </a:r>
+          </a:p>
+        </p:txBody>
+      </p:sp>
+      <p:sp>
+        <p:nvSpPr>
+          <p:cNvPr id="3" name="Rectangle 2"/>
           <p:cNvSpPr/>
           <p:nvPr/>
         </p:nvSpPr>
         <p:spPr>
           <a:xfrm>
-            <a:off x="594360" y="1170432"/>
+            <a:off x="594360" y="932688"/>
             <a:ext cx="10972800" cy="36576"/>
           </a:xfrm>
           <a:prstGeom prst="rect">
@@ -11716,23 +12068,25 @@
       </p:sp>
       <p:sp>
         <p:nvSpPr>
-          <p:cNvPr id="5" name="Rectangle 4"/>
+          <p:cNvPr id="4" name="Rectangle 3"/>
           <p:cNvSpPr/>
           <p:nvPr/>
         </p:nvSpPr>
         <p:spPr>
           <a:xfrm>
-            <a:off x="685800" y="1508760"/>
-            <a:ext cx="128016" cy="128016"/>
+            <a:off x="594360" y="1042416"/>
+            <a:ext cx="5440680" cy="5074920"/>
           </a:xfrm>
           <a:prstGeom prst="rect">
             <a:avLst/>
           </a:prstGeom>
           <a:solidFill>
-            <a:srgbClr val="B83A3A"/>
+            <a:srgbClr val="FDF8F8"/>
           </a:solidFill>
           <a:ln>
-            <a:noFill/>
+            <a:solidFill>
+              <a:srgbClr val="B83A3A"/>
+            </a:solidFill>
           </a:ln>
         </p:spPr>
         <p:style>
@@ -11759,14 +12113,49 @@
       </p:sp>
       <p:sp>
         <p:nvSpPr>
+          <p:cNvPr id="5" name="TextBox 4"/>
+          <p:cNvSpPr txBox="1"/>
+          <p:nvPr/>
+        </p:nvSpPr>
+        <p:spPr>
+          <a:xfrm>
+            <a:off x="777240" y="1179576"/>
+            <a:ext cx="5029200" cy="320040"/>
+          </a:xfrm>
+          <a:prstGeom prst="rect">
+            <a:avLst/>
+          </a:prstGeom>
+          <a:noFill/>
+        </p:spPr>
+        <p:txBody>
+          <a:bodyPr wrap="none">
+            <a:spAutoFit/>
+          </a:bodyPr>
+          <a:lstStyle/>
+          <a:p>
+            <a:pPr>
+              <a:defRPr sz="1500" b="1">
+                <a:solidFill>
+                  <a:srgbClr val="500000"/>
+                </a:solidFill>
+              </a:defRPr>
+            </a:pPr>
+            <a:r>
+              <a:t>Operational value</a:t>
+            </a:r>
+          </a:p>
+        </p:txBody>
+      </p:sp>
+      <p:sp>
+        <p:nvSpPr>
           <p:cNvPr id="6" name="TextBox 5"/>
           <p:cNvSpPr txBox="1"/>
           <p:nvPr/>
         </p:nvSpPr>
         <p:spPr>
           <a:xfrm>
-            <a:off x="960120" y="1417319"/>
-            <a:ext cx="10515600" cy="731520"/>
+            <a:off x="822960" y="1545336"/>
+            <a:ext cx="4983480" cy="4389120"/>
           </a:xfrm>
           <a:prstGeom prst="rect">
             <a:avLst/>
@@ -11780,14 +12169,77 @@
           <a:lstStyle/>
           <a:p>
             <a:pPr>
-              <a:defRPr sz="1500" b="0">
+              <a:spcAft>
+                <a:spcPts val="800"/>
+              </a:spcAft>
+              <a:defRPr sz="1400" b="0">
                 <a:solidFill>
                   <a:srgbClr val="1E293B"/>
                 </a:solidFill>
               </a:defRPr>
             </a:pPr>
             <a:r>
-              <a:t>Leadership endorsement of the Maintenance Strategy and PM frequencies</a:t>
+              <a:t>• Complete valve inventory across steam systems</a:t>
+            </a:r>
+          </a:p>
+          <a:p>
+            <a:pPr>
+              <a:spcAft>
+                <a:spcPts val="800"/>
+              </a:spcAft>
+              <a:defRPr sz="1400" b="0">
+                <a:solidFill>
+                  <a:srgbClr val="1E293B"/>
+                </a:solidFill>
+              </a:defRPr>
+            </a:pPr>
+            <a:r>
+              <a:t>• Visible compliance status by equipment and site</a:t>
+            </a:r>
+          </a:p>
+          <a:p>
+            <a:pPr>
+              <a:spcAft>
+                <a:spcPts val="800"/>
+              </a:spcAft>
+              <a:defRPr sz="1400" b="0">
+                <a:solidFill>
+                  <a:srgbClr val="1E293B"/>
+                </a:solidFill>
+              </a:defRPr>
+            </a:pPr>
+            <a:r>
+              <a:t>• Traceable history for audits and incidents</a:t>
+            </a:r>
+          </a:p>
+          <a:p>
+            <a:pPr>
+              <a:spcAft>
+                <a:spcPts val="800"/>
+              </a:spcAft>
+              <a:defRPr sz="1400" b="0">
+                <a:solidFill>
+                  <a:srgbClr val="1E293B"/>
+                </a:solidFill>
+              </a:defRPr>
+            </a:pPr>
+            <a:r>
+              <a:t>• Faster planning for Setpoint outages and swaps</a:t>
+            </a:r>
+          </a:p>
+          <a:p>
+            <a:pPr>
+              <a:spcAft>
+                <a:spcPts val="800"/>
+              </a:spcAft>
+              <a:defRPr sz="1400" b="0">
+                <a:solidFill>
+                  <a:srgbClr val="1E293B"/>
+                </a:solidFill>
+              </a:defRPr>
+            </a:pPr>
+            <a:r>
+              <a:t>• Reduced reliance on memory and scattered files</a:t>
             </a:r>
           </a:p>
         </p:txBody>
@@ -11800,17 +12252,19 @@
         </p:nvSpPr>
         <p:spPr>
           <a:xfrm>
-            <a:off x="685800" y="2377440"/>
-            <a:ext cx="128016" cy="128016"/>
+            <a:off x="6172200" y="1042416"/>
+            <a:ext cx="5440680" cy="5074920"/>
           </a:xfrm>
           <a:prstGeom prst="rect">
             <a:avLst/>
           </a:prstGeom>
           <a:solidFill>
-            <a:srgbClr val="B83A3A"/>
+            <a:srgbClr val="E0F2FE"/>
           </a:solidFill>
           <a:ln>
-            <a:noFill/>
+            <a:solidFill>
+              <a:srgbClr val="B83A3A"/>
+            </a:solidFill>
           </a:ln>
         </p:spPr>
         <p:style>
@@ -11843,8 +12297,43 @@
         </p:nvSpPr>
         <p:spPr>
           <a:xfrm>
-            <a:off x="960120" y="2286000"/>
-            <a:ext cx="10515600" cy="731520"/>
+            <a:off x="6355080" y="1179576"/>
+            <a:ext cx="5029200" cy="320040"/>
+          </a:xfrm>
+          <a:prstGeom prst="rect">
+            <a:avLst/>
+          </a:prstGeom>
+          <a:noFill/>
+        </p:spPr>
+        <p:txBody>
+          <a:bodyPr wrap="none">
+            <a:spAutoFit/>
+          </a:bodyPr>
+          <a:lstStyle/>
+          <a:p>
+            <a:pPr>
+              <a:defRPr sz="1500" b="1">
+                <a:solidFill>
+                  <a:srgbClr val="500000"/>
+                </a:solidFill>
+              </a:defRPr>
+            </a:pPr>
+            <a:r>
+              <a:t>Strategic value</a:t>
+            </a:r>
+          </a:p>
+        </p:txBody>
+      </p:sp>
+      <p:sp>
+        <p:nvSpPr>
+          <p:cNvPr id="9" name="TextBox 8"/>
+          <p:cNvSpPr txBox="1"/>
+          <p:nvPr/>
+        </p:nvSpPr>
+        <p:spPr>
+          <a:xfrm>
+            <a:off x="6400800" y="1545336"/>
+            <a:ext cx="4983480" cy="4389120"/>
           </a:xfrm>
           <a:prstGeom prst="rect">
             <a:avLst/>
@@ -11858,255 +12347,84 @@
           <a:lstStyle/>
           <a:p>
             <a:pPr>
-              <a:defRPr sz="1500" b="0">
+              <a:spcAft>
+                <a:spcPts val="800"/>
+              </a:spcAft>
+              <a:defRPr sz="1400" b="0">
                 <a:solidFill>
                   <a:srgbClr val="1E293B"/>
                 </a:solidFill>
               </a:defRPr>
             </a:pPr>
             <a:r>
-              <a:t>Decision on manual lever testing policy (Section 3 — management choice)</a:t>
-            </a:r>
-          </a:p>
-        </p:txBody>
-      </p:sp>
-      <p:sp>
-        <p:nvSpPr>
-          <p:cNvPr id="9" name="Rectangle 8"/>
-          <p:cNvSpPr/>
-          <p:nvPr/>
-        </p:nvSpPr>
-        <p:spPr>
-          <a:xfrm>
-            <a:off x="685800" y="3246120"/>
-            <a:ext cx="128016" cy="128016"/>
-          </a:xfrm>
-          <a:prstGeom prst="rect">
-            <a:avLst/>
-          </a:prstGeom>
-          <a:solidFill>
-            <a:srgbClr val="B83A3A"/>
-          </a:solidFill>
-          <a:ln>
-            <a:noFill/>
-          </a:ln>
-        </p:spPr>
-        <p:style>
-          <a:lnRef idx="1">
-            <a:schemeClr val="accent1"/>
-          </a:lnRef>
-          <a:fillRef idx="3">
-            <a:schemeClr val="accent1"/>
-          </a:fillRef>
-          <a:effectRef idx="2">
-            <a:schemeClr val="accent1"/>
-          </a:effectRef>
-          <a:fontRef idx="minor">
-            <a:schemeClr val="lt1"/>
-          </a:fontRef>
-        </p:style>
-        <p:txBody>
-          <a:bodyPr rtlCol="0" anchor="ctr"/>
-          <a:lstStyle/>
-          <a:p>
-            <a:pPr algn="ctr"/>
+              <a:t>• Code-aligned maintenance strategy document</a:t>
+            </a:r>
+          </a:p>
+          <a:p>
+            <a:pPr>
+              <a:spcAft>
+                <a:spcPts val="800"/>
+              </a:spcAft>
+              <a:defRPr sz="1400" b="0">
+                <a:solidFill>
+                  <a:srgbClr val="1E293B"/>
+                </a:solidFill>
+              </a:defRPr>
+            </a:pPr>
+            <a:r>
+              <a:t>• Foundation for CMMS integration and spare pooling</a:t>
+            </a:r>
+          </a:p>
+          <a:p>
+            <a:pPr>
+              <a:spcAft>
+                <a:spcPts val="800"/>
+              </a:spcAft>
+              <a:defRPr sz="1400" b="0">
+                <a:solidFill>
+                  <a:srgbClr val="1E293B"/>
+                </a:solidFill>
+              </a:defRPr>
+            </a:pPr>
+            <a:r>
+              <a:t>• Data to support capital requests for spares</a:t>
+            </a:r>
+          </a:p>
+          <a:p>
+            <a:pPr>
+              <a:spcAft>
+                <a:spcPts val="800"/>
+              </a:spcAft>
+              <a:defRPr sz="1400" b="0">
+                <a:solidFill>
+                  <a:srgbClr val="1E293B"/>
+                </a:solidFill>
+              </a:defRPr>
+            </a:pPr>
+            <a:r>
+              <a:t>• Leadership-ready reporting via dashboard &amp; Excel</a:t>
+            </a:r>
+          </a:p>
+          <a:p>
+            <a:pPr>
+              <a:spcAft>
+                <a:spcPts val="800"/>
+              </a:spcAft>
+              <a:defRPr sz="1400" b="0">
+                <a:solidFill>
+                  <a:srgbClr val="1E293B"/>
+                </a:solidFill>
+              </a:defRPr>
+            </a:pPr>
+            <a:r>
+              <a:t>• Sustainable program ownership within UES</a:t>
+            </a:r>
           </a:p>
         </p:txBody>
       </p:sp>
       <p:sp>
         <p:nvSpPr>
           <p:cNvPr id="10" name="TextBox 9"/>
-          <p:cNvSpPr txBox="1"/>
-          <p:nvPr/>
-        </p:nvSpPr>
-        <p:spPr>
-          <a:xfrm>
-            <a:off x="960120" y="3154679"/>
-            <a:ext cx="10515600" cy="731520"/>
-          </a:xfrm>
-          <a:prstGeom prst="rect">
-            <a:avLst/>
-          </a:prstGeom>
-          <a:noFill/>
-        </p:spPr>
-        <p:txBody>
-          <a:bodyPr wrap="square">
-            <a:spAutoFit/>
-          </a:bodyPr>
-          <a:lstStyle/>
-          <a:p>
-            <a:pPr>
-              <a:defRPr sz="1500" b="0">
-                <a:solidFill>
-                  <a:srgbClr val="1E293B"/>
-                </a:solidFill>
-              </a:defRPr>
-            </a:pPr>
-            <a:r>
-              <a:t>Approve spare-acquisition prioritization for no-spare locations</a:t>
-            </a:r>
-          </a:p>
-        </p:txBody>
-      </p:sp>
-      <p:sp>
-        <p:nvSpPr>
-          <p:cNvPr id="11" name="Rectangle 10"/>
-          <p:cNvSpPr/>
-          <p:nvPr/>
-        </p:nvSpPr>
-        <p:spPr>
-          <a:xfrm>
-            <a:off x="685800" y="4114799"/>
-            <a:ext cx="128016" cy="128016"/>
-          </a:xfrm>
-          <a:prstGeom prst="rect">
-            <a:avLst/>
-          </a:prstGeom>
-          <a:solidFill>
-            <a:srgbClr val="B83A3A"/>
-          </a:solidFill>
-          <a:ln>
-            <a:noFill/>
-          </a:ln>
-        </p:spPr>
-        <p:style>
-          <a:lnRef idx="1">
-            <a:schemeClr val="accent1"/>
-          </a:lnRef>
-          <a:fillRef idx="3">
-            <a:schemeClr val="accent1"/>
-          </a:fillRef>
-          <a:effectRef idx="2">
-            <a:schemeClr val="accent1"/>
-          </a:effectRef>
-          <a:fontRef idx="minor">
-            <a:schemeClr val="lt1"/>
-          </a:fontRef>
-        </p:style>
-        <p:txBody>
-          <a:bodyPr rtlCol="0" anchor="ctr"/>
-          <a:lstStyle/>
-          <a:p>
-            <a:pPr algn="ctr"/>
-          </a:p>
-        </p:txBody>
-      </p:sp>
-      <p:sp>
-        <p:nvSpPr>
-          <p:cNvPr id="12" name="TextBox 11"/>
-          <p:cNvSpPr txBox="1"/>
-          <p:nvPr/>
-        </p:nvSpPr>
-        <p:spPr>
-          <a:xfrm>
-            <a:off x="960120" y="4023359"/>
-            <a:ext cx="10515600" cy="731520"/>
-          </a:xfrm>
-          <a:prstGeom prst="rect">
-            <a:avLst/>
-          </a:prstGeom>
-          <a:noFill/>
-        </p:spPr>
-        <p:txBody>
-          <a:bodyPr wrap="square">
-            <a:spAutoFit/>
-          </a:bodyPr>
-          <a:lstStyle/>
-          <a:p>
-            <a:pPr>
-              <a:defRPr sz="1500" b="0">
-                <a:solidFill>
-                  <a:srgbClr val="1E293B"/>
-                </a:solidFill>
-              </a:defRPr>
-            </a:pPr>
-            <a:r>
-              <a:t>Continue populating dashboard with remaining field discoveries (walkdowns in progress)</a:t>
-            </a:r>
-          </a:p>
-        </p:txBody>
-      </p:sp>
-      <p:sp>
-        <p:nvSpPr>
-          <p:cNvPr id="13" name="Rectangle 12"/>
-          <p:cNvSpPr/>
-          <p:nvPr/>
-        </p:nvSpPr>
-        <p:spPr>
-          <a:xfrm>
-            <a:off x="685800" y="4983479"/>
-            <a:ext cx="128016" cy="128016"/>
-          </a:xfrm>
-          <a:prstGeom prst="rect">
-            <a:avLst/>
-          </a:prstGeom>
-          <a:solidFill>
-            <a:srgbClr val="B83A3A"/>
-          </a:solidFill>
-          <a:ln>
-            <a:noFill/>
-          </a:ln>
-        </p:spPr>
-        <p:style>
-          <a:lnRef idx="1">
-            <a:schemeClr val="accent1"/>
-          </a:lnRef>
-          <a:fillRef idx="3">
-            <a:schemeClr val="accent1"/>
-          </a:fillRef>
-          <a:effectRef idx="2">
-            <a:schemeClr val="accent1"/>
-          </a:effectRef>
-          <a:fontRef idx="minor">
-            <a:schemeClr val="lt1"/>
-          </a:fontRef>
-        </p:style>
-        <p:txBody>
-          <a:bodyPr rtlCol="0" anchor="ctr"/>
-          <a:lstStyle/>
-          <a:p>
-            <a:pPr algn="ctr"/>
-          </a:p>
-        </p:txBody>
-      </p:sp>
-      <p:sp>
-        <p:nvSpPr>
-          <p:cNvPr id="14" name="TextBox 13"/>
-          <p:cNvSpPr txBox="1"/>
-          <p:nvPr/>
-        </p:nvSpPr>
-        <p:spPr>
-          <a:xfrm>
-            <a:off x="960120" y="4892040"/>
-            <a:ext cx="10515600" cy="731520"/>
-          </a:xfrm>
-          <a:prstGeom prst="rect">
-            <a:avLst/>
-          </a:prstGeom>
-          <a:noFill/>
-        </p:spPr>
-        <p:txBody>
-          <a:bodyPr wrap="square">
-            <a:spAutoFit/>
-          </a:bodyPr>
-          <a:lstStyle/>
-          <a:p>
-            <a:pPr>
-              <a:defRPr sz="1500" b="0">
-                <a:solidFill>
-                  <a:srgbClr val="1E293B"/>
-                </a:solidFill>
-              </a:defRPr>
-            </a:pPr>
-            <a:r>
-              <a:t>Integrate Position Tags and Inventory IDs fleet-wide on physical valve tags</a:t>
-            </a:r>
-          </a:p>
-        </p:txBody>
-      </p:sp>
-      <p:sp>
-        <p:nvSpPr>
-          <p:cNvPr id="15" name="TextBox 14"/>
           <p:cNvSpPr txBox="1"/>
           <p:nvPr/>
         </p:nvSpPr>
@@ -12148,6 +12466,648 @@
 </file>
 
 <file path=ppt/slides/slide27.xml><?xml version="1.0" encoding="utf-8"?>
+<p:sld xmlns:a="http://schemas.openxmlformats.org/drawingml/2006/main" xmlns:p="http://schemas.openxmlformats.org/presentationml/2006/main" xmlns:r="http://schemas.openxmlformats.org/officeDocument/2006/relationships">
+  <p:cSld>
+    <p:bg>
+      <p:bgPr>
+        <a:solidFill>
+          <a:srgbClr val="FFFFFF"/>
+        </a:solidFill>
+        <a:effectLst/>
+      </p:bgPr>
+    </p:bg>
+    <p:spTree>
+      <p:nvGrpSpPr>
+        <p:cNvPr id="1" name=""/>
+        <p:cNvGrpSpPr/>
+        <p:nvPr/>
+      </p:nvGrpSpPr>
+      <p:grpSpPr/>
+      <p:sp>
+        <p:nvSpPr>
+          <p:cNvPr id="2" name="TextBox 1"/>
+          <p:cNvSpPr txBox="1"/>
+          <p:nvPr/>
+        </p:nvSpPr>
+        <p:spPr>
+          <a:xfrm>
+            <a:off x="594360" y="292608"/>
+            <a:ext cx="11064240" cy="594360"/>
+          </a:xfrm>
+          <a:prstGeom prst="rect">
+            <a:avLst/>
+          </a:prstGeom>
+          <a:noFill/>
+        </p:spPr>
+        <p:txBody>
+          <a:bodyPr wrap="none">
+            <a:spAutoFit/>
+          </a:bodyPr>
+          <a:lstStyle/>
+          <a:p>
+            <a:pPr>
+              <a:defRPr sz="2800" b="1">
+                <a:solidFill>
+                  <a:srgbClr val="500000"/>
+                </a:solidFill>
+              </a:defRPr>
+            </a:pPr>
+            <a:r>
+              <a:t>Recommended Next Steps</a:t>
+            </a:r>
+          </a:p>
+        </p:txBody>
+      </p:sp>
+      <p:sp>
+        <p:nvSpPr>
+          <p:cNvPr id="3" name="TextBox 2"/>
+          <p:cNvSpPr txBox="1"/>
+          <p:nvPr/>
+        </p:nvSpPr>
+        <p:spPr>
+          <a:xfrm>
+            <a:off x="594360" y="822960"/>
+            <a:ext cx="11064240" cy="347472"/>
+          </a:xfrm>
+          <a:prstGeom prst="rect">
+            <a:avLst/>
+          </a:prstGeom>
+          <a:noFill/>
+        </p:spPr>
+        <p:txBody>
+          <a:bodyPr wrap="none">
+            <a:spAutoFit/>
+          </a:bodyPr>
+          <a:lstStyle/>
+          <a:p>
+            <a:pPr>
+              <a:defRPr sz="1300" b="0">
+                <a:solidFill>
+                  <a:srgbClr val="64748B"/>
+                </a:solidFill>
+              </a:defRPr>
+            </a:pPr>
+            <a:r>
+              <a:t>Leadership decisions to sustain the program</a:t>
+            </a:r>
+          </a:p>
+        </p:txBody>
+      </p:sp>
+      <p:sp>
+        <p:nvSpPr>
+          <p:cNvPr id="4" name="Rectangle 3"/>
+          <p:cNvSpPr/>
+          <p:nvPr/>
+        </p:nvSpPr>
+        <p:spPr>
+          <a:xfrm>
+            <a:off x="594360" y="1170432"/>
+            <a:ext cx="10972800" cy="36576"/>
+          </a:xfrm>
+          <a:prstGeom prst="rect">
+            <a:avLst/>
+          </a:prstGeom>
+          <a:solidFill>
+            <a:srgbClr val="B83A3A"/>
+          </a:solidFill>
+          <a:ln>
+            <a:noFill/>
+          </a:ln>
+        </p:spPr>
+        <p:style>
+          <a:lnRef idx="1">
+            <a:schemeClr val="accent1"/>
+          </a:lnRef>
+          <a:fillRef idx="3">
+            <a:schemeClr val="accent1"/>
+          </a:fillRef>
+          <a:effectRef idx="2">
+            <a:schemeClr val="accent1"/>
+          </a:effectRef>
+          <a:fontRef idx="minor">
+            <a:schemeClr val="lt1"/>
+          </a:fontRef>
+        </p:style>
+        <p:txBody>
+          <a:bodyPr rtlCol="0" anchor="ctr"/>
+          <a:lstStyle/>
+          <a:p>
+            <a:pPr algn="ctr"/>
+          </a:p>
+        </p:txBody>
+      </p:sp>
+      <p:sp>
+        <p:nvSpPr>
+          <p:cNvPr id="5" name="Rectangle 4"/>
+          <p:cNvSpPr/>
+          <p:nvPr/>
+        </p:nvSpPr>
+        <p:spPr>
+          <a:xfrm>
+            <a:off x="685800" y="1508760"/>
+            <a:ext cx="128016" cy="128016"/>
+          </a:xfrm>
+          <a:prstGeom prst="rect">
+            <a:avLst/>
+          </a:prstGeom>
+          <a:solidFill>
+            <a:srgbClr val="B83A3A"/>
+          </a:solidFill>
+          <a:ln>
+            <a:noFill/>
+          </a:ln>
+        </p:spPr>
+        <p:style>
+          <a:lnRef idx="1">
+            <a:schemeClr val="accent1"/>
+          </a:lnRef>
+          <a:fillRef idx="3">
+            <a:schemeClr val="accent1"/>
+          </a:fillRef>
+          <a:effectRef idx="2">
+            <a:schemeClr val="accent1"/>
+          </a:effectRef>
+          <a:fontRef idx="minor">
+            <a:schemeClr val="lt1"/>
+          </a:fontRef>
+        </p:style>
+        <p:txBody>
+          <a:bodyPr rtlCol="0" anchor="ctr"/>
+          <a:lstStyle/>
+          <a:p>
+            <a:pPr algn="ctr"/>
+          </a:p>
+        </p:txBody>
+      </p:sp>
+      <p:sp>
+        <p:nvSpPr>
+          <p:cNvPr id="6" name="TextBox 5"/>
+          <p:cNvSpPr txBox="1"/>
+          <p:nvPr/>
+        </p:nvSpPr>
+        <p:spPr>
+          <a:xfrm>
+            <a:off x="960120" y="1417319"/>
+            <a:ext cx="10515600" cy="731520"/>
+          </a:xfrm>
+          <a:prstGeom prst="rect">
+            <a:avLst/>
+          </a:prstGeom>
+          <a:noFill/>
+        </p:spPr>
+        <p:txBody>
+          <a:bodyPr wrap="square">
+            <a:spAutoFit/>
+          </a:bodyPr>
+          <a:lstStyle/>
+          <a:p>
+            <a:pPr>
+              <a:defRPr sz="1500" b="0">
+                <a:solidFill>
+                  <a:srgbClr val="1E293B"/>
+                </a:solidFill>
+              </a:defRPr>
+            </a:pPr>
+            <a:r>
+              <a:t>Leadership endorsement of the Maintenance Strategy and PM frequencies</a:t>
+            </a:r>
+          </a:p>
+        </p:txBody>
+      </p:sp>
+      <p:sp>
+        <p:nvSpPr>
+          <p:cNvPr id="7" name="Rectangle 6"/>
+          <p:cNvSpPr/>
+          <p:nvPr/>
+        </p:nvSpPr>
+        <p:spPr>
+          <a:xfrm>
+            <a:off x="685800" y="2377440"/>
+            <a:ext cx="128016" cy="128016"/>
+          </a:xfrm>
+          <a:prstGeom prst="rect">
+            <a:avLst/>
+          </a:prstGeom>
+          <a:solidFill>
+            <a:srgbClr val="B83A3A"/>
+          </a:solidFill>
+          <a:ln>
+            <a:noFill/>
+          </a:ln>
+        </p:spPr>
+        <p:style>
+          <a:lnRef idx="1">
+            <a:schemeClr val="accent1"/>
+          </a:lnRef>
+          <a:fillRef idx="3">
+            <a:schemeClr val="accent1"/>
+          </a:fillRef>
+          <a:effectRef idx="2">
+            <a:schemeClr val="accent1"/>
+          </a:effectRef>
+          <a:fontRef idx="minor">
+            <a:schemeClr val="lt1"/>
+          </a:fontRef>
+        </p:style>
+        <p:txBody>
+          <a:bodyPr rtlCol="0" anchor="ctr"/>
+          <a:lstStyle/>
+          <a:p>
+            <a:pPr algn="ctr"/>
+          </a:p>
+        </p:txBody>
+      </p:sp>
+      <p:sp>
+        <p:nvSpPr>
+          <p:cNvPr id="8" name="TextBox 7"/>
+          <p:cNvSpPr txBox="1"/>
+          <p:nvPr/>
+        </p:nvSpPr>
+        <p:spPr>
+          <a:xfrm>
+            <a:off x="960120" y="2286000"/>
+            <a:ext cx="10515600" cy="731520"/>
+          </a:xfrm>
+          <a:prstGeom prst="rect">
+            <a:avLst/>
+          </a:prstGeom>
+          <a:noFill/>
+        </p:spPr>
+        <p:txBody>
+          <a:bodyPr wrap="square">
+            <a:spAutoFit/>
+          </a:bodyPr>
+          <a:lstStyle/>
+          <a:p>
+            <a:pPr>
+              <a:defRPr sz="1500" b="0">
+                <a:solidFill>
+                  <a:srgbClr val="1E293B"/>
+                </a:solidFill>
+              </a:defRPr>
+            </a:pPr>
+            <a:r>
+              <a:t>Decision on manual lever testing policy (Section 3 — management choice)</a:t>
+            </a:r>
+          </a:p>
+        </p:txBody>
+      </p:sp>
+      <p:sp>
+        <p:nvSpPr>
+          <p:cNvPr id="9" name="Rectangle 8"/>
+          <p:cNvSpPr/>
+          <p:nvPr/>
+        </p:nvSpPr>
+        <p:spPr>
+          <a:xfrm>
+            <a:off x="685800" y="3246120"/>
+            <a:ext cx="128016" cy="128016"/>
+          </a:xfrm>
+          <a:prstGeom prst="rect">
+            <a:avLst/>
+          </a:prstGeom>
+          <a:solidFill>
+            <a:srgbClr val="B83A3A"/>
+          </a:solidFill>
+          <a:ln>
+            <a:noFill/>
+          </a:ln>
+        </p:spPr>
+        <p:style>
+          <a:lnRef idx="1">
+            <a:schemeClr val="accent1"/>
+          </a:lnRef>
+          <a:fillRef idx="3">
+            <a:schemeClr val="accent1"/>
+          </a:fillRef>
+          <a:effectRef idx="2">
+            <a:schemeClr val="accent1"/>
+          </a:effectRef>
+          <a:fontRef idx="minor">
+            <a:schemeClr val="lt1"/>
+          </a:fontRef>
+        </p:style>
+        <p:txBody>
+          <a:bodyPr rtlCol="0" anchor="ctr"/>
+          <a:lstStyle/>
+          <a:p>
+            <a:pPr algn="ctr"/>
+          </a:p>
+        </p:txBody>
+      </p:sp>
+      <p:sp>
+        <p:nvSpPr>
+          <p:cNvPr id="10" name="TextBox 9"/>
+          <p:cNvSpPr txBox="1"/>
+          <p:nvPr/>
+        </p:nvSpPr>
+        <p:spPr>
+          <a:xfrm>
+            <a:off x="960120" y="3154679"/>
+            <a:ext cx="10515600" cy="731520"/>
+          </a:xfrm>
+          <a:prstGeom prst="rect">
+            <a:avLst/>
+          </a:prstGeom>
+          <a:noFill/>
+        </p:spPr>
+        <p:txBody>
+          <a:bodyPr wrap="square">
+            <a:spAutoFit/>
+          </a:bodyPr>
+          <a:lstStyle/>
+          <a:p>
+            <a:pPr>
+              <a:defRPr sz="1500" b="0">
+                <a:solidFill>
+                  <a:srgbClr val="1E293B"/>
+                </a:solidFill>
+              </a:defRPr>
+            </a:pPr>
+            <a:r>
+              <a:t>Approve 3-year location rotation plan for commercial replacements and recert spend</a:t>
+            </a:r>
+          </a:p>
+        </p:txBody>
+      </p:sp>
+      <p:sp>
+        <p:nvSpPr>
+          <p:cNvPr id="11" name="Rectangle 10"/>
+          <p:cNvSpPr/>
+          <p:nvPr/>
+        </p:nvSpPr>
+        <p:spPr>
+          <a:xfrm>
+            <a:off x="685800" y="4114799"/>
+            <a:ext cx="128016" cy="128016"/>
+          </a:xfrm>
+          <a:prstGeom prst="rect">
+            <a:avLst/>
+          </a:prstGeom>
+          <a:solidFill>
+            <a:srgbClr val="B83A3A"/>
+          </a:solidFill>
+          <a:ln>
+            <a:noFill/>
+          </a:ln>
+        </p:spPr>
+        <p:style>
+          <a:lnRef idx="1">
+            <a:schemeClr val="accent1"/>
+          </a:lnRef>
+          <a:fillRef idx="3">
+            <a:schemeClr val="accent1"/>
+          </a:fillRef>
+          <a:effectRef idx="2">
+            <a:schemeClr val="accent1"/>
+          </a:effectRef>
+          <a:fontRef idx="minor">
+            <a:schemeClr val="lt1"/>
+          </a:fontRef>
+        </p:style>
+        <p:txBody>
+          <a:bodyPr rtlCol="0" anchor="ctr"/>
+          <a:lstStyle/>
+          <a:p>
+            <a:pPr algn="ctr"/>
+          </a:p>
+        </p:txBody>
+      </p:sp>
+      <p:sp>
+        <p:nvSpPr>
+          <p:cNvPr id="12" name="TextBox 11"/>
+          <p:cNvSpPr txBox="1"/>
+          <p:nvPr/>
+        </p:nvSpPr>
+        <p:spPr>
+          <a:xfrm>
+            <a:off x="960120" y="4023359"/>
+            <a:ext cx="10515600" cy="731520"/>
+          </a:xfrm>
+          <a:prstGeom prst="rect">
+            <a:avLst/>
+          </a:prstGeom>
+          <a:noFill/>
+        </p:spPr>
+        <p:txBody>
+          <a:bodyPr wrap="square">
+            <a:spAutoFit/>
+          </a:bodyPr>
+          <a:lstStyle/>
+          <a:p>
+            <a:pPr>
+              <a:defRPr sz="1500" b="0">
+                <a:solidFill>
+                  <a:srgbClr val="1E293B"/>
+                </a:solidFill>
+              </a:defRPr>
+            </a:pPr>
+            <a:r>
+              <a:t>Approve spare-acquisition prioritization for no-spare locations</a:t>
+            </a:r>
+          </a:p>
+        </p:txBody>
+      </p:sp>
+      <p:sp>
+        <p:nvSpPr>
+          <p:cNvPr id="13" name="Rectangle 12"/>
+          <p:cNvSpPr/>
+          <p:nvPr/>
+        </p:nvSpPr>
+        <p:spPr>
+          <a:xfrm>
+            <a:off x="685800" y="4983479"/>
+            <a:ext cx="128016" cy="128016"/>
+          </a:xfrm>
+          <a:prstGeom prst="rect">
+            <a:avLst/>
+          </a:prstGeom>
+          <a:solidFill>
+            <a:srgbClr val="B83A3A"/>
+          </a:solidFill>
+          <a:ln>
+            <a:noFill/>
+          </a:ln>
+        </p:spPr>
+        <p:style>
+          <a:lnRef idx="1">
+            <a:schemeClr val="accent1"/>
+          </a:lnRef>
+          <a:fillRef idx="3">
+            <a:schemeClr val="accent1"/>
+          </a:fillRef>
+          <a:effectRef idx="2">
+            <a:schemeClr val="accent1"/>
+          </a:effectRef>
+          <a:fontRef idx="minor">
+            <a:schemeClr val="lt1"/>
+          </a:fontRef>
+        </p:style>
+        <p:txBody>
+          <a:bodyPr rtlCol="0" anchor="ctr"/>
+          <a:lstStyle/>
+          <a:p>
+            <a:pPr algn="ctr"/>
+          </a:p>
+        </p:txBody>
+      </p:sp>
+      <p:sp>
+        <p:nvSpPr>
+          <p:cNvPr id="14" name="TextBox 13"/>
+          <p:cNvSpPr txBox="1"/>
+          <p:nvPr/>
+        </p:nvSpPr>
+        <p:spPr>
+          <a:xfrm>
+            <a:off x="960120" y="4892040"/>
+            <a:ext cx="10515600" cy="731520"/>
+          </a:xfrm>
+          <a:prstGeom prst="rect">
+            <a:avLst/>
+          </a:prstGeom>
+          <a:noFill/>
+        </p:spPr>
+        <p:txBody>
+          <a:bodyPr wrap="square">
+            <a:spAutoFit/>
+          </a:bodyPr>
+          <a:lstStyle/>
+          <a:p>
+            <a:pPr>
+              <a:defRPr sz="1500" b="0">
+                <a:solidFill>
+                  <a:srgbClr val="1E293B"/>
+                </a:solidFill>
+              </a:defRPr>
+            </a:pPr>
+            <a:r>
+              <a:t>Continue populating dashboard with remaining field discoveries (walkdowns in progress)</a:t>
+            </a:r>
+          </a:p>
+        </p:txBody>
+      </p:sp>
+      <p:sp>
+        <p:nvSpPr>
+          <p:cNvPr id="15" name="Rectangle 14"/>
+          <p:cNvSpPr/>
+          <p:nvPr/>
+        </p:nvSpPr>
+        <p:spPr>
+          <a:xfrm>
+            <a:off x="685800" y="5852159"/>
+            <a:ext cx="128016" cy="128016"/>
+          </a:xfrm>
+          <a:prstGeom prst="rect">
+            <a:avLst/>
+          </a:prstGeom>
+          <a:solidFill>
+            <a:srgbClr val="B83A3A"/>
+          </a:solidFill>
+          <a:ln>
+            <a:noFill/>
+          </a:ln>
+        </p:spPr>
+        <p:style>
+          <a:lnRef idx="1">
+            <a:schemeClr val="accent1"/>
+          </a:lnRef>
+          <a:fillRef idx="3">
+            <a:schemeClr val="accent1"/>
+          </a:fillRef>
+          <a:effectRef idx="2">
+            <a:schemeClr val="accent1"/>
+          </a:effectRef>
+          <a:fontRef idx="minor">
+            <a:schemeClr val="lt1"/>
+          </a:fontRef>
+        </p:style>
+        <p:txBody>
+          <a:bodyPr rtlCol="0" anchor="ctr"/>
+          <a:lstStyle/>
+          <a:p>
+            <a:pPr algn="ctr"/>
+          </a:p>
+        </p:txBody>
+      </p:sp>
+      <p:sp>
+        <p:nvSpPr>
+          <p:cNvPr id="16" name="TextBox 15"/>
+          <p:cNvSpPr txBox="1"/>
+          <p:nvPr/>
+        </p:nvSpPr>
+        <p:spPr>
+          <a:xfrm>
+            <a:off x="960120" y="5760720"/>
+            <a:ext cx="10515600" cy="731520"/>
+          </a:xfrm>
+          <a:prstGeom prst="rect">
+            <a:avLst/>
+          </a:prstGeom>
+          <a:noFill/>
+        </p:spPr>
+        <p:txBody>
+          <a:bodyPr wrap="square">
+            <a:spAutoFit/>
+          </a:bodyPr>
+          <a:lstStyle/>
+          <a:p>
+            <a:pPr>
+              <a:defRPr sz="1500" b="0">
+                <a:solidFill>
+                  <a:srgbClr val="1E293B"/>
+                </a:solidFill>
+              </a:defRPr>
+            </a:pPr>
+            <a:r>
+              <a:t>Integrate Position Tags and Inventory IDs fleet-wide on physical valve tags</a:t>
+            </a:r>
+          </a:p>
+        </p:txBody>
+      </p:sp>
+      <p:sp>
+        <p:nvSpPr>
+          <p:cNvPr id="17" name="TextBox 16"/>
+          <p:cNvSpPr txBox="1"/>
+          <p:nvPr/>
+        </p:nvSpPr>
+        <p:spPr>
+          <a:xfrm>
+            <a:off x="11475720" y="6565392"/>
+            <a:ext cx="548640" cy="228600"/>
+          </a:xfrm>
+          <a:prstGeom prst="rect">
+            <a:avLst/>
+          </a:prstGeom>
+          <a:noFill/>
+        </p:spPr>
+        <p:txBody>
+          <a:bodyPr wrap="none">
+            <a:spAutoFit/>
+          </a:bodyPr>
+          <a:lstStyle/>
+          <a:p>
+            <a:pPr algn="r">
+              <a:defRPr sz="900" b="0">
+                <a:solidFill>
+                  <a:srgbClr val="94A3B8"/>
+                </a:solidFill>
+              </a:defRPr>
+            </a:pPr>
+            <a:r>
+              <a:t>26</a:t>
+            </a:r>
+          </a:p>
+        </p:txBody>
+      </p:sp>
+    </p:spTree>
+  </p:cSld>
+  <p:clrMapOvr>
+    <a:masterClrMapping/>
+  </p:clrMapOvr>
+</p:sld>
+</file>
+
+<file path=ppt/slides/slide28.xml><?xml version="1.0" encoding="utf-8"?>
 <p:sld xmlns:a="http://schemas.openxmlformats.org/drawingml/2006/main" xmlns:p="http://schemas.openxmlformats.org/presentationml/2006/main" xmlns:r="http://schemas.openxmlformats.org/officeDocument/2006/relationships">
   <p:cSld>
     <p:bg>
@@ -12308,7 +13268,7 @@
               </a:defRPr>
             </a:pPr>
             <a:r>
-              <a:t>26</a:t>
+              <a:t>27</a:t>
             </a:r>
           </a:p>
         </p:txBody>

</xml_diff>